<commit_message>
School project: redesigned defence deck (navy/gold system, stat cards, takeaway strips)
</commit_message>
<xml_diff>
--- a/docs/school-project/FAILURES_Defence_Slides.pptx
+++ b/docs/school-project/FAILURES_Defence_Slides.pptx
@@ -4163,7 +4163,7 @@
             <a:avLst/>
           </a:prstGeom>
           <a:solidFill>
-            <a:srgbClr val="1F3864"/>
+            <a:srgbClr val="1B3A5C"/>
           </a:solidFill>
           <a:ln>
             <a:noFill/>
@@ -4193,14 +4193,57 @@
       </p:sp>
       <p:sp>
         <p:nvSpPr>
-          <p:cNvPr id="3" name="TextBox 2"/>
+          <p:cNvPr id="3" name="Rectangle 2"/>
+          <p:cNvSpPr/>
+          <p:nvPr/>
+        </p:nvSpPr>
+        <p:spPr>
+          <a:xfrm>
+            <a:off x="0" y="0"/>
+            <a:ext cx="12188952" cy="82296"/>
+          </a:xfrm>
+          <a:prstGeom prst="rect">
+            <a:avLst/>
+          </a:prstGeom>
+          <a:solidFill>
+            <a:srgbClr val="C98A1F"/>
+          </a:solidFill>
+          <a:ln>
+            <a:noFill/>
+          </a:ln>
+        </p:spPr>
+        <p:style>
+          <a:lnRef idx="1">
+            <a:schemeClr val="accent1"/>
+          </a:lnRef>
+          <a:fillRef idx="3">
+            <a:schemeClr val="accent1"/>
+          </a:fillRef>
+          <a:effectRef idx="2">
+            <a:schemeClr val="accent1"/>
+          </a:effectRef>
+          <a:fontRef idx="minor">
+            <a:schemeClr val="lt1"/>
+          </a:fontRef>
+        </p:style>
+        <p:txBody>
+          <a:bodyPr rtlCol="0" anchor="ctr"/>
+          <a:lstStyle/>
+          <a:p>
+            <a:pPr algn="ctr"/>
+          </a:p>
+        </p:txBody>
+      </p:sp>
+      <p:sp>
+        <p:nvSpPr>
+          <p:cNvPr id="4" name="TextBox 3"/>
           <p:cNvSpPr txBox="1"/>
           <p:nvPr/>
         </p:nvSpPr>
         <p:spPr>
           <a:xfrm>
-            <a:off x="914400" y="1097280"/>
-            <a:ext cx="10360152" cy="2926080"/>
+            <a:off x="914400" y="640080"/>
+            <a:ext cx="10360152" cy="365760"/>
           </a:xfrm>
           <a:prstGeom prst="rect">
             <a:avLst/>
@@ -4213,9 +4256,44 @@
           </a:bodyPr>
           <a:lstStyle/>
           <a:p>
+            <a:pPr algn="ctr"/>
+            <a:r>
+              <a:rPr sz="1300">
+                <a:solidFill>
+                  <a:srgbClr val="C98A1F"/>
+                </a:solidFill>
+                <a:latin typeface="Calibri"/>
+              </a:rPr>
+              <a:t>MIVA OPEN UNIVERSITY  ·  SCHOOL OF COMPUTING</a:t>
+            </a:r>
+          </a:p>
+        </p:txBody>
+      </p:sp>
+      <p:sp>
+        <p:nvSpPr>
+          <p:cNvPr id="5" name="TextBox 4"/>
+          <p:cNvSpPr txBox="1"/>
+          <p:nvPr/>
+        </p:nvSpPr>
+        <p:spPr>
+          <a:xfrm>
+            <a:off x="914400" y="1325880"/>
+            <a:ext cx="10360152" cy="2743200"/>
+          </a:xfrm>
+          <a:prstGeom prst="rect">
+            <a:avLst/>
+          </a:prstGeom>
+          <a:noFill/>
+        </p:spPr>
+        <p:txBody>
+          <a:bodyPr wrap="none">
+            <a:spAutoFit/>
+          </a:bodyPr>
+          <a:lstStyle/>
+          <a:p>
             <a:pPr algn="ctr">
               <a:spcAft>
-                <a:spcPts val="600"/>
+                <a:spcPts val="200"/>
               </a:spcAft>
             </a:pPr>
             <a:r>
@@ -4231,11 +4309,11 @@
           <a:p>
             <a:pPr algn="ctr">
               <a:spcAft>
-                <a:spcPts val="600"/>
+                <a:spcPts val="200"/>
               </a:spcAft>
             </a:pPr>
             <a:r>
-              <a:rPr sz="2400" b="1">
+              <a:rPr sz="3000" b="1">
                 <a:solidFill>
                   <a:srgbClr val="FFFFFF"/>
                 </a:solidFill>
@@ -4247,11 +4325,11 @@
           <a:p>
             <a:pPr algn="ctr">
               <a:spcAft>
-                <a:spcPts val="600"/>
+                <a:spcPts val="200"/>
               </a:spcAft>
             </a:pPr>
             <a:r>
-              <a:rPr sz="2400" b="1">
+              <a:rPr sz="3000" b="1">
                 <a:solidFill>
                   <a:srgbClr val="FFFFFF"/>
                 </a:solidFill>
@@ -4264,14 +4342,68 @@
       </p:sp>
       <p:sp>
         <p:nvSpPr>
-          <p:cNvPr id="4" name="TextBox 3"/>
+          <p:cNvPr id="6" name="Rounded Rectangle 5"/>
+          <p:cNvSpPr/>
+          <p:nvPr/>
+        </p:nvSpPr>
+        <p:spPr>
+          <a:xfrm>
+            <a:off x="4937760" y="4160520"/>
+            <a:ext cx="2313432" cy="502920"/>
+          </a:xfrm>
+          <a:prstGeom prst="roundRect">
+            <a:avLst>
+              <a:gd name="adj" fmla="val 50000"/>
+            </a:avLst>
+          </a:prstGeom>
+          <a:solidFill>
+            <a:srgbClr val="C98A1F"/>
+          </a:solidFill>
+          <a:ln>
+            <a:noFill/>
+          </a:ln>
+        </p:spPr>
+        <p:style>
+          <a:lnRef idx="1">
+            <a:schemeClr val="accent1"/>
+          </a:lnRef>
+          <a:fillRef idx="3">
+            <a:schemeClr val="accent1"/>
+          </a:fillRef>
+          <a:effectRef idx="2">
+            <a:schemeClr val="accent1"/>
+          </a:effectRef>
+          <a:fontRef idx="minor">
+            <a:schemeClr val="lt1"/>
+          </a:fontRef>
+        </p:style>
+        <p:txBody>
+          <a:bodyPr rtlCol="0" anchor="ctr"/>
+          <a:lstStyle/>
+          <a:p>
+            <a:pPr algn="ctr"/>
+            <a:r>
+              <a:rPr sz="1500" b="1">
+                <a:solidFill>
+                  <a:srgbClr val="1B3A5C"/>
+                </a:solidFill>
+                <a:latin typeface="Calibri"/>
+              </a:rPr>
+              <a:t>2023/C/SENG/0351</a:t>
+            </a:r>
+          </a:p>
+        </p:txBody>
+      </p:sp>
+      <p:sp>
+        <p:nvSpPr>
+          <p:cNvPr id="7" name="TextBox 6"/>
           <p:cNvSpPr txBox="1"/>
           <p:nvPr/>
         </p:nvSpPr>
         <p:spPr>
           <a:xfrm>
-            <a:off x="914400" y="4389120"/>
-            <a:ext cx="10360152" cy="2011680"/>
+            <a:off x="914400" y="4892040"/>
+            <a:ext cx="10360152" cy="1645920"/>
           </a:xfrm>
           <a:prstGeom prst="rect">
             <a:avLst/>
@@ -4290,13 +4422,13 @@
               </a:spcAft>
             </a:pPr>
             <a:r>
-              <a:rPr sz="1500">
+              <a:rPr sz="1700" b="1">
                 <a:solidFill>
                   <a:srgbClr val="FFFFFF"/>
                 </a:solidFill>
                 <a:latin typeface="Calibri"/>
               </a:rPr>
-              <a:t>OLUWAMAYOWA KALEJAIYE  —  2023/C/SENG/0351</a:t>
+              <a:t>OLUWAMAYOWA KALEJAIYE</a:t>
             </a:r>
           </a:p>
           <a:p>
@@ -4306,29 +4438,13 @@
               </a:spcAft>
             </a:pPr>
             <a:r>
-              <a:rPr sz="1500">
+              <a:rPr sz="1400" b="0">
                 <a:solidFill>
                   <a:srgbClr val="FFFFFF"/>
                 </a:solidFill>
                 <a:latin typeface="Calibri"/>
               </a:rPr>
-              <a:t>Department of Software Engineering, School of Computing, Miva Open University</a:t>
-            </a:r>
-          </a:p>
-          <a:p>
-            <a:pPr algn="ctr">
-              <a:spcAft>
-                <a:spcPts val="400"/>
-              </a:spcAft>
-            </a:pPr>
-            <a:r>
-              <a:rPr sz="1500">
-                <a:solidFill>
-                  <a:srgbClr val="FFFFFF"/>
-                </a:solidFill>
-                <a:latin typeface="Calibri"/>
-              </a:rPr>
-              <a:t>Supervisor: Ijegwa Acheme, Ph.D   —   July, 2026</a:t>
+              <a:t>Supervisor: Ijegwa Acheme, Ph.D   ·   July, 2026</a:t>
             </a:r>
           </a:p>
         </p:txBody>
@@ -4359,8 +4475,8 @@
         </p:nvSpPr>
         <p:spPr>
           <a:xfrm>
-            <a:off x="548640" y="228600"/>
-            <a:ext cx="11064240" cy="914400"/>
+            <a:off x="548640" y="201168"/>
+            <a:ext cx="11064240" cy="292608"/>
           </a:xfrm>
           <a:prstGeom prst="rect">
             <a:avLst/>
@@ -4374,33 +4490,67 @@
           <a:lstStyle/>
           <a:p>
             <a:r>
-              <a:rPr sz="2800" b="1">
-                <a:solidFill>
-                  <a:srgbClr val="1F3864"/>
-                </a:solidFill>
-                <a:latin typeface="Calibri"/>
-              </a:rPr>
-              <a:t>Discussion and objectives check</a:t>
-            </a:r>
-          </a:p>
-        </p:txBody>
-      </p:sp>
-      <p:sp>
-        <p:nvSpPr>
-          <p:cNvPr id="3" name="Rectangle 2"/>
+              <a:rPr sz="1200" b="1">
+                <a:solidFill>
+                  <a:srgbClr val="C98A1F"/>
+                </a:solidFill>
+                <a:latin typeface="Calibri"/>
+              </a:rPr>
+              <a:t>09 · DISCUSSION</a:t>
+            </a:r>
+          </a:p>
+        </p:txBody>
+      </p:sp>
+      <p:sp>
+        <p:nvSpPr>
+          <p:cNvPr id="3" name="TextBox 2"/>
+          <p:cNvSpPr txBox="1"/>
+          <p:nvPr/>
+        </p:nvSpPr>
+        <p:spPr>
+          <a:xfrm>
+            <a:off x="548640" y="475488"/>
+            <a:ext cx="11064240" cy="685800"/>
+          </a:xfrm>
+          <a:prstGeom prst="rect">
+            <a:avLst/>
+          </a:prstGeom>
+          <a:noFill/>
+        </p:spPr>
+        <p:txBody>
+          <a:bodyPr wrap="none">
+            <a:spAutoFit/>
+          </a:bodyPr>
+          <a:lstStyle/>
+          <a:p>
+            <a:r>
+              <a:rPr sz="2700" b="1">
+                <a:solidFill>
+                  <a:srgbClr val="1B3A5C"/>
+                </a:solidFill>
+                <a:latin typeface="Calibri"/>
+              </a:rPr>
+              <a:t>Three lessons, five objectives met</a:t>
+            </a:r>
+          </a:p>
+        </p:txBody>
+      </p:sp>
+      <p:sp>
+        <p:nvSpPr>
+          <p:cNvPr id="4" name="Rectangle 3"/>
           <p:cNvSpPr/>
           <p:nvPr/>
         </p:nvSpPr>
         <p:spPr>
           <a:xfrm>
-            <a:off x="548640" y="1051560"/>
-            <a:ext cx="11064240" cy="25400"/>
+            <a:off x="548640" y="1207008"/>
+            <a:ext cx="1463040" cy="38100"/>
           </a:xfrm>
           <a:prstGeom prst="rect">
             <a:avLst/>
           </a:prstGeom>
           <a:solidFill>
-            <a:srgbClr val="1F3864"/>
+            <a:srgbClr val="C98A1F"/>
           </a:solidFill>
           <a:ln>
             <a:noFill/>
@@ -4430,14 +4580,83 @@
       </p:sp>
       <p:sp>
         <p:nvSpPr>
-          <p:cNvPr id="4" name="TextBox 3"/>
+          <p:cNvPr id="5" name="TextBox 4"/>
           <p:cNvSpPr txBox="1"/>
           <p:nvPr/>
         </p:nvSpPr>
         <p:spPr>
           <a:xfrm>
-            <a:off x="548640" y="1371600"/>
-            <a:ext cx="11064240" cy="4754880"/>
+            <a:off x="548640" y="6419088"/>
+            <a:ext cx="11091672" cy="320040"/>
+          </a:xfrm>
+          <a:prstGeom prst="rect">
+            <a:avLst/>
+          </a:prstGeom>
+          <a:noFill/>
+        </p:spPr>
+        <p:txBody>
+          <a:bodyPr wrap="none">
+            <a:spAutoFit/>
+          </a:bodyPr>
+          <a:lstStyle/>
+          <a:p>
+            <a:r>
+              <a:rPr sz="1000">
+                <a:solidFill>
+                  <a:srgbClr val="6B6B6B"/>
+                </a:solidFill>
+                <a:latin typeface="Calibri"/>
+              </a:rPr>
+              <a:t>Failures — Final Year Project Defence</a:t>
+            </a:r>
+          </a:p>
+        </p:txBody>
+      </p:sp>
+      <p:sp>
+        <p:nvSpPr>
+          <p:cNvPr id="6" name="TextBox 5"/>
+          <p:cNvSpPr txBox="1"/>
+          <p:nvPr/>
+        </p:nvSpPr>
+        <p:spPr>
+          <a:xfrm>
+            <a:off x="10424160" y="6419088"/>
+            <a:ext cx="1216152" cy="320040"/>
+          </a:xfrm>
+          <a:prstGeom prst="rect">
+            <a:avLst/>
+          </a:prstGeom>
+          <a:noFill/>
+        </p:spPr>
+        <p:txBody>
+          <a:bodyPr wrap="none">
+            <a:spAutoFit/>
+          </a:bodyPr>
+          <a:lstStyle/>
+          <a:p>
+            <a:pPr algn="r"/>
+            <a:r>
+              <a:rPr sz="1000">
+                <a:solidFill>
+                  <a:srgbClr val="6B6B6B"/>
+                </a:solidFill>
+                <a:latin typeface="Calibri"/>
+              </a:rPr>
+              <a:t>10 / 11</a:t>
+            </a:r>
+          </a:p>
+        </p:txBody>
+      </p:sp>
+      <p:sp>
+        <p:nvSpPr>
+          <p:cNvPr id="7" name="TextBox 6"/>
+          <p:cNvSpPr txBox="1"/>
+          <p:nvPr/>
+        </p:nvSpPr>
+        <p:spPr>
+          <a:xfrm>
+            <a:off x="548640" y="1508760"/>
+            <a:ext cx="5394960" cy="4023360"/>
           </a:xfrm>
           <a:prstGeom prst="rect">
             <a:avLst/>
@@ -4456,9 +4675,18 @@
               </a:spcAft>
             </a:pPr>
             <a:r>
-              <a:rPr sz="1800">
-                <a:solidFill>
-                  <a:srgbClr val="333333"/>
+              <a:rPr sz="1800" b="1">
+                <a:solidFill>
+                  <a:srgbClr val="C98A1F"/>
+                </a:solidFill>
+                <a:latin typeface="Calibri"/>
+              </a:rPr>
+              <a:t>▸ </a:t>
+            </a:r>
+            <a:r>
+              <a:rPr sz="1800" b="1">
+                <a:solidFill>
+                  <a:srgbClr val="1B3A5C"/>
                 </a:solidFill>
                 <a:latin typeface="Calibri"/>
               </a:rPr>
@@ -4472,9 +4700,18 @@
               </a:spcAft>
             </a:pPr>
             <a:r>
-              <a:rPr sz="1800">
-                <a:solidFill>
-                  <a:srgbClr val="333333"/>
+              <a:rPr sz="1800" b="1">
+                <a:solidFill>
+                  <a:srgbClr val="C98A1F"/>
+                </a:solidFill>
+                <a:latin typeface="Calibri"/>
+              </a:rPr>
+              <a:t>▸ </a:t>
+            </a:r>
+            <a:r>
+              <a:rPr sz="1800" b="1">
+                <a:solidFill>
+                  <a:srgbClr val="1B3A5C"/>
                 </a:solidFill>
                 <a:latin typeface="Calibri"/>
               </a:rPr>
@@ -4488,62 +4725,37 @@
               </a:spcAft>
             </a:pPr>
             <a:r>
-              <a:rPr sz="1800">
-                <a:solidFill>
-                  <a:srgbClr val="333333"/>
-                </a:solidFill>
-                <a:latin typeface="Calibri"/>
-              </a:rPr>
-              <a:t>All five objectives met — each maps to evidence in Chapter 4.</a:t>
-            </a:r>
-          </a:p>
-        </p:txBody>
-      </p:sp>
-      <p:sp>
-        <p:nvSpPr>
-          <p:cNvPr id="5" name="TextBox 4"/>
-          <p:cNvSpPr txBox="1"/>
-          <p:nvPr/>
-        </p:nvSpPr>
-        <p:spPr>
-          <a:xfrm>
-            <a:off x="548640" y="6446520"/>
-            <a:ext cx="11064240" cy="320040"/>
-          </a:xfrm>
-          <a:prstGeom prst="rect">
-            <a:avLst/>
-          </a:prstGeom>
-          <a:noFill/>
-        </p:spPr>
-        <p:txBody>
-          <a:bodyPr wrap="none">
-            <a:spAutoFit/>
-          </a:bodyPr>
-          <a:lstStyle/>
-          <a:p>
-            <a:r>
-              <a:rPr sz="1100">
-                <a:solidFill>
-                  <a:srgbClr val="595659"/>
-                </a:solidFill>
-                <a:latin typeface="Calibri"/>
-              </a:rPr>
-              <a:t>Failures — Final Year Project Defence</a:t>
+              <a:rPr sz="1800" b="1">
+                <a:solidFill>
+                  <a:srgbClr val="C98A1F"/>
+                </a:solidFill>
+                <a:latin typeface="Calibri"/>
+              </a:rPr>
+              <a:t>▸ </a:t>
+            </a:r>
+            <a:r>
+              <a:rPr sz="1800" b="1">
+                <a:solidFill>
+                  <a:srgbClr val="1B3A5C"/>
+                </a:solidFill>
+                <a:latin typeface="Calibri"/>
+              </a:rPr>
+              <a:t>More code is the mechanism: +39% volume is pending records and reconciliation — the resilience itself.</a:t>
             </a:r>
           </a:p>
         </p:txBody>
       </p:sp>
       <p:graphicFrame>
         <p:nvGraphicFramePr>
-          <p:cNvPr id="6" name="Table 5"/>
+          <p:cNvPr id="8" name="Table 7"/>
           <p:cNvGraphicFramePr>
             <a:graphicFrameLocks noGrp="1"/>
           </p:cNvGraphicFramePr>
           <p:nvPr/>
         </p:nvGraphicFramePr>
         <p:xfrm>
-          <a:off x="6126480" y="3931920"/>
-          <a:ext cx="5486400" cy="2194560"/>
+          <a:off x="6217920" y="2834640"/>
+          <a:ext cx="5394960" cy="2377440"/>
         </p:xfrm>
         <a:graphic>
           <a:graphicData uri="http://schemas.openxmlformats.org/drawingml/2006/table">
@@ -4552,18 +4764,19 @@
                 <a:tableStyleId>{5C22544A-7EE6-4342-B048-85BDC9FD1C3A}</a:tableStyleId>
               </a:tblPr>
               <a:tblGrid>
-                <a:gridCol w="1828800"/>
-                <a:gridCol w="1828800"/>
-                <a:gridCol w="1828800"/>
+                <a:gridCol w="1798320"/>
+                <a:gridCol w="1798320"/>
+                <a:gridCol w="1798320"/>
               </a:tblGrid>
-              <a:tr h="365760">
+              <a:tr h="396240">
                 <a:tc>
                   <a:txBody>
                     <a:bodyPr/>
                     <a:lstStyle/>
                     <a:p>
+                      <a:pPr algn="l"/>
                       <a:r>
-                        <a:rPr sz="1300" b="1">
+                        <a:rPr sz="1200" b="1">
                           <a:solidFill>
                             <a:srgbClr val="FFFFFF"/>
                           </a:solidFill>
@@ -4573,9 +4786,9 @@
                       </a:r>
                     </a:p>
                   </a:txBody>
-                  <a:tcPr>
+                  <a:tcPr anchor="t">
                     <a:solidFill>
-                      <a:srgbClr val="1F3864"/>
+                      <a:srgbClr val="1B3A5C"/>
                     </a:solidFill>
                   </a:tcPr>
                 </a:tc>
@@ -4584,8 +4797,9 @@
                     <a:bodyPr/>
                     <a:lstStyle/>
                     <a:p>
+                      <a:pPr algn="l"/>
                       <a:r>
-                        <a:rPr sz="1300" b="1">
+                        <a:rPr sz="1200" b="1">
                           <a:solidFill>
                             <a:srgbClr val="FFFFFF"/>
                           </a:solidFill>
@@ -4595,9 +4809,9 @@
                       </a:r>
                     </a:p>
                   </a:txBody>
-                  <a:tcPr>
+                  <a:tcPr anchor="t">
                     <a:solidFill>
-                      <a:srgbClr val="1F3864"/>
+                      <a:srgbClr val="1B3A5C"/>
                     </a:solidFill>
                   </a:tcPr>
                 </a:tc>
@@ -4606,8 +4820,9 @@
                     <a:bodyPr/>
                     <a:lstStyle/>
                     <a:p>
+                      <a:pPr algn="ctr"/>
                       <a:r>
-                        <a:rPr sz="1300" b="1">
+                        <a:rPr sz="1200" b="1">
                           <a:solidFill>
                             <a:srgbClr val="FFFFFF"/>
                           </a:solidFill>
@@ -4617,23 +4832,24 @@
                       </a:r>
                     </a:p>
                   </a:txBody>
-                  <a:tcPr>
+                  <a:tcPr anchor="t">
                     <a:solidFill>
-                      <a:srgbClr val="1F3864"/>
+                      <a:srgbClr val="1B3A5C"/>
                     </a:solidFill>
                   </a:tcPr>
                 </a:tc>
               </a:tr>
-              <a:tr h="365760">
+              <a:tr h="396240">
                 <a:tc>
                   <a:txBody>
                     <a:bodyPr/>
                     <a:lstStyle/>
                     <a:p>
+                      <a:pPr algn="l"/>
                       <a:r>
-                        <a:rPr sz="1300" b="0">
+                        <a:rPr sz="1200" b="0">
                           <a:solidFill>
-                            <a:srgbClr val="333333"/>
+                            <a:srgbClr val="262626"/>
                           </a:solidFill>
                           <a:latin typeface="Calibri"/>
                         </a:rPr>
@@ -4641,17 +4857,18 @@
                       </a:r>
                     </a:p>
                   </a:txBody>
-                  <a:tcPr/>
+                  <a:tcPr anchor="t"/>
                 </a:tc>
                 <a:tc>
                   <a:txBody>
                     <a:bodyPr/>
                     <a:lstStyle/>
                     <a:p>
+                      <a:pPr algn="l"/>
                       <a:r>
-                        <a:rPr sz="1300" b="0">
+                        <a:rPr sz="1200" b="0">
                           <a:solidFill>
-                            <a:srgbClr val="333333"/>
+                            <a:srgbClr val="262626"/>
                           </a:solidFill>
                           <a:latin typeface="Calibri"/>
                         </a:rPr>
@@ -4659,17 +4876,18 @@
                       </a:r>
                     </a:p>
                   </a:txBody>
-                  <a:tcPr/>
+                  <a:tcPr anchor="t"/>
                 </a:tc>
                 <a:tc>
                   <a:txBody>
                     <a:bodyPr/>
                     <a:lstStyle/>
                     <a:p>
+                      <a:pPr algn="ctr"/>
                       <a:r>
-                        <a:rPr sz="1300" b="0">
+                        <a:rPr sz="1200" b="0">
                           <a:solidFill>
-                            <a:srgbClr val="333333"/>
+                            <a:srgbClr val="262626"/>
                           </a:solidFill>
                           <a:latin typeface="Calibri"/>
                         </a:rPr>
@@ -4677,19 +4895,20 @@
                       </a:r>
                     </a:p>
                   </a:txBody>
-                  <a:tcPr/>
+                  <a:tcPr anchor="t"/>
                 </a:tc>
               </a:tr>
-              <a:tr h="365760">
+              <a:tr h="396240">
                 <a:tc>
                   <a:txBody>
                     <a:bodyPr/>
                     <a:lstStyle/>
                     <a:p>
+                      <a:pPr algn="l"/>
                       <a:r>
-                        <a:rPr sz="1300" b="0">
+                        <a:rPr sz="1200" b="0">
                           <a:solidFill>
-                            <a:srgbClr val="333333"/>
+                            <a:srgbClr val="262626"/>
                           </a:solidFill>
                           <a:latin typeface="Calibri"/>
                         </a:rPr>
@@ -4697,17 +4916,18 @@
                       </a:r>
                     </a:p>
                   </a:txBody>
-                  <a:tcPr/>
+                  <a:tcPr anchor="t"/>
                 </a:tc>
                 <a:tc>
                   <a:txBody>
                     <a:bodyPr/>
                     <a:lstStyle/>
                     <a:p>
+                      <a:pPr algn="l"/>
                       <a:r>
-                        <a:rPr sz="1300" b="0">
+                        <a:rPr sz="1200" b="0">
                           <a:solidFill>
-                            <a:srgbClr val="333333"/>
+                            <a:srgbClr val="262626"/>
                           </a:solidFill>
                           <a:latin typeface="Calibri"/>
                         </a:rPr>
@@ -4715,17 +4935,18 @@
                       </a:r>
                     </a:p>
                   </a:txBody>
-                  <a:tcPr/>
+                  <a:tcPr anchor="t"/>
                 </a:tc>
                 <a:tc>
                   <a:txBody>
                     <a:bodyPr/>
                     <a:lstStyle/>
                     <a:p>
+                      <a:pPr algn="ctr"/>
                       <a:r>
-                        <a:rPr sz="1300" b="0">
+                        <a:rPr sz="1200" b="0">
                           <a:solidFill>
-                            <a:srgbClr val="333333"/>
+                            <a:srgbClr val="262626"/>
                           </a:solidFill>
                           <a:latin typeface="Calibri"/>
                         </a:rPr>
@@ -4733,19 +4954,20 @@
                       </a:r>
                     </a:p>
                   </a:txBody>
-                  <a:tcPr/>
+                  <a:tcPr anchor="t"/>
                 </a:tc>
               </a:tr>
-              <a:tr h="365760">
+              <a:tr h="396240">
                 <a:tc>
                   <a:txBody>
                     <a:bodyPr/>
                     <a:lstStyle/>
                     <a:p>
+                      <a:pPr algn="l"/>
                       <a:r>
-                        <a:rPr sz="1300" b="0">
+                        <a:rPr sz="1200" b="0">
                           <a:solidFill>
-                            <a:srgbClr val="333333"/>
+                            <a:srgbClr val="262626"/>
                           </a:solidFill>
                           <a:latin typeface="Calibri"/>
                         </a:rPr>
@@ -4753,17 +4975,18 @@
                       </a:r>
                     </a:p>
                   </a:txBody>
-                  <a:tcPr/>
+                  <a:tcPr anchor="t"/>
                 </a:tc>
                 <a:tc>
                   <a:txBody>
                     <a:bodyPr/>
                     <a:lstStyle/>
                     <a:p>
+                      <a:pPr algn="l"/>
                       <a:r>
-                        <a:rPr sz="1300" b="0">
+                        <a:rPr sz="1200" b="0">
                           <a:solidFill>
-                            <a:srgbClr val="333333"/>
+                            <a:srgbClr val="262626"/>
                           </a:solidFill>
                           <a:latin typeface="Calibri"/>
                         </a:rPr>
@@ -4771,17 +4994,18 @@
                       </a:r>
                     </a:p>
                   </a:txBody>
-                  <a:tcPr/>
+                  <a:tcPr anchor="t"/>
                 </a:tc>
                 <a:tc>
                   <a:txBody>
                     <a:bodyPr/>
                     <a:lstStyle/>
                     <a:p>
+                      <a:pPr algn="ctr"/>
                       <a:r>
-                        <a:rPr sz="1300" b="0">
+                        <a:rPr sz="1200" b="0">
                           <a:solidFill>
-                            <a:srgbClr val="333333"/>
+                            <a:srgbClr val="262626"/>
                           </a:solidFill>
                           <a:latin typeface="Calibri"/>
                         </a:rPr>
@@ -4789,19 +5013,20 @@
                       </a:r>
                     </a:p>
                   </a:txBody>
-                  <a:tcPr/>
+                  <a:tcPr anchor="t"/>
                 </a:tc>
               </a:tr>
-              <a:tr h="365760">
+              <a:tr h="396240">
                 <a:tc>
                   <a:txBody>
                     <a:bodyPr/>
                     <a:lstStyle/>
                     <a:p>
+                      <a:pPr algn="l"/>
                       <a:r>
-                        <a:rPr sz="1300" b="0">
+                        <a:rPr sz="1200" b="0">
                           <a:solidFill>
-                            <a:srgbClr val="333333"/>
+                            <a:srgbClr val="262626"/>
                           </a:solidFill>
                           <a:latin typeface="Calibri"/>
                         </a:rPr>
@@ -4809,17 +5034,18 @@
                       </a:r>
                     </a:p>
                   </a:txBody>
-                  <a:tcPr/>
+                  <a:tcPr anchor="t"/>
                 </a:tc>
                 <a:tc>
                   <a:txBody>
                     <a:bodyPr/>
                     <a:lstStyle/>
                     <a:p>
+                      <a:pPr algn="l"/>
                       <a:r>
-                        <a:rPr sz="1300" b="0">
+                        <a:rPr sz="1200" b="0">
                           <a:solidFill>
-                            <a:srgbClr val="333333"/>
+                            <a:srgbClr val="262626"/>
                           </a:solidFill>
                           <a:latin typeface="Calibri"/>
                         </a:rPr>
@@ -4827,17 +5053,18 @@
                       </a:r>
                     </a:p>
                   </a:txBody>
-                  <a:tcPr/>
+                  <a:tcPr anchor="t"/>
                 </a:tc>
                 <a:tc>
                   <a:txBody>
                     <a:bodyPr/>
                     <a:lstStyle/>
                     <a:p>
+                      <a:pPr algn="ctr"/>
                       <a:r>
-                        <a:rPr sz="1300" b="0">
+                        <a:rPr sz="1200" b="0">
                           <a:solidFill>
-                            <a:srgbClr val="333333"/>
+                            <a:srgbClr val="262626"/>
                           </a:solidFill>
                           <a:latin typeface="Calibri"/>
                         </a:rPr>
@@ -4845,19 +5072,20 @@
                       </a:r>
                     </a:p>
                   </a:txBody>
-                  <a:tcPr/>
+                  <a:tcPr anchor="t"/>
                 </a:tc>
               </a:tr>
-              <a:tr h="365760">
+              <a:tr h="396240">
                 <a:tc>
                   <a:txBody>
                     <a:bodyPr/>
                     <a:lstStyle/>
                     <a:p>
+                      <a:pPr algn="l"/>
                       <a:r>
-                        <a:rPr sz="1300" b="0">
+                        <a:rPr sz="1200" b="0">
                           <a:solidFill>
-                            <a:srgbClr val="333333"/>
+                            <a:srgbClr val="262626"/>
                           </a:solidFill>
                           <a:latin typeface="Calibri"/>
                         </a:rPr>
@@ -4865,17 +5093,18 @@
                       </a:r>
                     </a:p>
                   </a:txBody>
-                  <a:tcPr/>
+                  <a:tcPr anchor="t"/>
                 </a:tc>
                 <a:tc>
                   <a:txBody>
                     <a:bodyPr/>
                     <a:lstStyle/>
                     <a:p>
+                      <a:pPr algn="l"/>
                       <a:r>
-                        <a:rPr sz="1300" b="0">
+                        <a:rPr sz="1200" b="0">
                           <a:solidFill>
-                            <a:srgbClr val="333333"/>
+                            <a:srgbClr val="262626"/>
                           </a:solidFill>
                           <a:latin typeface="Calibri"/>
                         </a:rPr>
@@ -4883,17 +5112,18 @@
                       </a:r>
                     </a:p>
                   </a:txBody>
-                  <a:tcPr/>
+                  <a:tcPr anchor="t"/>
                 </a:tc>
                 <a:tc>
                   <a:txBody>
                     <a:bodyPr/>
                     <a:lstStyle/>
                     <a:p>
+                      <a:pPr algn="ctr"/>
                       <a:r>
-                        <a:rPr sz="1300" b="0">
+                        <a:rPr sz="1200" b="0">
                           <a:solidFill>
-                            <a:srgbClr val="333333"/>
+                            <a:srgbClr val="262626"/>
                           </a:solidFill>
                           <a:latin typeface="Calibri"/>
                         </a:rPr>
@@ -4901,7 +5131,7 @@
                       </a:r>
                     </a:p>
                   </a:txBody>
-                  <a:tcPr/>
+                  <a:tcPr anchor="t"/>
                 </a:tc>
               </a:tr>
             </a:tbl>
@@ -4934,8 +5164,8 @@
         </p:nvSpPr>
         <p:spPr>
           <a:xfrm>
-            <a:off x="548640" y="228600"/>
-            <a:ext cx="11064240" cy="914400"/>
+            <a:off x="548640" y="201168"/>
+            <a:ext cx="11064240" cy="292608"/>
           </a:xfrm>
           <a:prstGeom prst="rect">
             <a:avLst/>
@@ -4949,33 +5179,67 @@
           <a:lstStyle/>
           <a:p>
             <a:r>
-              <a:rPr sz="2800" b="1">
-                <a:solidFill>
-                  <a:srgbClr val="1F3864"/>
-                </a:solidFill>
-                <a:latin typeface="Calibri"/>
-              </a:rPr>
-              <a:t>Conclusion</a:t>
-            </a:r>
-          </a:p>
-        </p:txBody>
-      </p:sp>
-      <p:sp>
-        <p:nvSpPr>
-          <p:cNvPr id="3" name="Rectangle 2"/>
+              <a:rPr sz="1200" b="1">
+                <a:solidFill>
+                  <a:srgbClr val="C98A1F"/>
+                </a:solidFill>
+                <a:latin typeface="Calibri"/>
+              </a:rPr>
+              <a:t>10 · CONCLUSION</a:t>
+            </a:r>
+          </a:p>
+        </p:txBody>
+      </p:sp>
+      <p:sp>
+        <p:nvSpPr>
+          <p:cNvPr id="3" name="TextBox 2"/>
+          <p:cNvSpPr txBox="1"/>
+          <p:nvPr/>
+        </p:nvSpPr>
+        <p:spPr>
+          <a:xfrm>
+            <a:off x="548640" y="475488"/>
+            <a:ext cx="11064240" cy="685800"/>
+          </a:xfrm>
+          <a:prstGeom prst="rect">
+            <a:avLst/>
+          </a:prstGeom>
+          <a:noFill/>
+        </p:spPr>
+        <p:txBody>
+          <a:bodyPr wrap="none">
+            <a:spAutoFit/>
+          </a:bodyPr>
+          <a:lstStyle/>
+          <a:p>
+            <a:r>
+              <a:rPr sz="2700" b="1">
+                <a:solidFill>
+                  <a:srgbClr val="1B3A5C"/>
+                </a:solidFill>
+                <a:latin typeface="Calibri"/>
+              </a:rPr>
+              <a:t>A cheap, reproducible floor for resilience practice</a:t>
+            </a:r>
+          </a:p>
+        </p:txBody>
+      </p:sp>
+      <p:sp>
+        <p:nvSpPr>
+          <p:cNvPr id="4" name="Rectangle 3"/>
           <p:cNvSpPr/>
           <p:nvPr/>
         </p:nvSpPr>
         <p:spPr>
           <a:xfrm>
-            <a:off x="548640" y="1051560"/>
-            <a:ext cx="11064240" cy="25400"/>
+            <a:off x="548640" y="1207008"/>
+            <a:ext cx="1463040" cy="38100"/>
           </a:xfrm>
           <a:prstGeom prst="rect">
             <a:avLst/>
           </a:prstGeom>
           <a:solidFill>
-            <a:srgbClr val="1F3864"/>
+            <a:srgbClr val="C98A1F"/>
           </a:solidFill>
           <a:ln>
             <a:noFill/>
@@ -5005,14 +5269,83 @@
       </p:sp>
       <p:sp>
         <p:nvSpPr>
-          <p:cNvPr id="4" name="TextBox 3"/>
+          <p:cNvPr id="5" name="TextBox 4"/>
           <p:cNvSpPr txBox="1"/>
           <p:nvPr/>
         </p:nvSpPr>
         <p:spPr>
           <a:xfrm>
-            <a:off x="548640" y="1371600"/>
-            <a:ext cx="11064240" cy="4754880"/>
+            <a:off x="548640" y="6419088"/>
+            <a:ext cx="11091672" cy="320040"/>
+          </a:xfrm>
+          <a:prstGeom prst="rect">
+            <a:avLst/>
+          </a:prstGeom>
+          <a:noFill/>
+        </p:spPr>
+        <p:txBody>
+          <a:bodyPr wrap="none">
+            <a:spAutoFit/>
+          </a:bodyPr>
+          <a:lstStyle/>
+          <a:p>
+            <a:r>
+              <a:rPr sz="1000">
+                <a:solidFill>
+                  <a:srgbClr val="6B6B6B"/>
+                </a:solidFill>
+                <a:latin typeface="Calibri"/>
+              </a:rPr>
+              <a:t>Failures — Final Year Project Defence</a:t>
+            </a:r>
+          </a:p>
+        </p:txBody>
+      </p:sp>
+      <p:sp>
+        <p:nvSpPr>
+          <p:cNvPr id="6" name="TextBox 5"/>
+          <p:cNvSpPr txBox="1"/>
+          <p:nvPr/>
+        </p:nvSpPr>
+        <p:spPr>
+          <a:xfrm>
+            <a:off x="10424160" y="6419088"/>
+            <a:ext cx="1216152" cy="320040"/>
+          </a:xfrm>
+          <a:prstGeom prst="rect">
+            <a:avLst/>
+          </a:prstGeom>
+          <a:noFill/>
+        </p:spPr>
+        <p:txBody>
+          <a:bodyPr wrap="none">
+            <a:spAutoFit/>
+          </a:bodyPr>
+          <a:lstStyle/>
+          <a:p>
+            <a:pPr algn="r"/>
+            <a:r>
+              <a:rPr sz="1000">
+                <a:solidFill>
+                  <a:srgbClr val="6B6B6B"/>
+                </a:solidFill>
+                <a:latin typeface="Calibri"/>
+              </a:rPr>
+              <a:t>11 / 11</a:t>
+            </a:r>
+          </a:p>
+        </p:txBody>
+      </p:sp>
+      <p:sp>
+        <p:nvSpPr>
+          <p:cNvPr id="7" name="TextBox 6"/>
+          <p:cNvSpPr txBox="1"/>
+          <p:nvPr/>
+        </p:nvSpPr>
+        <p:spPr>
+          <a:xfrm>
+            <a:off x="548640" y="1508760"/>
+            <a:ext cx="11091672" cy="2834640"/>
           </a:xfrm>
           <a:prstGeom prst="rect">
             <a:avLst/>
@@ -5031,9 +5364,18 @@
               </a:spcAft>
             </a:pPr>
             <a:r>
-              <a:rPr sz="1800">
-                <a:solidFill>
-                  <a:srgbClr val="333333"/>
+              <a:rPr sz="1900" b="1">
+                <a:solidFill>
+                  <a:srgbClr val="C98A1F"/>
+                </a:solidFill>
+                <a:latin typeface="Calibri"/>
+              </a:rPr>
+              <a:t>▸ </a:t>
+            </a:r>
+            <a:r>
+              <a:rPr sz="1900" b="1">
+                <a:solidFill>
+                  <a:srgbClr val="1B3A5C"/>
                 </a:solidFill>
                 <a:latin typeface="Calibri"/>
               </a:rPr>
@@ -5047,9 +5389,18 @@
               </a:spcAft>
             </a:pPr>
             <a:r>
-              <a:rPr sz="1800">
-                <a:solidFill>
-                  <a:srgbClr val="333333"/>
+              <a:rPr sz="1900" b="1">
+                <a:solidFill>
+                  <a:srgbClr val="C98A1F"/>
+                </a:solidFill>
+                <a:latin typeface="Calibri"/>
+              </a:rPr>
+              <a:t>▸ </a:t>
+            </a:r>
+            <a:r>
+              <a:rPr sz="1900" b="1">
+                <a:solidFill>
+                  <a:srgbClr val="1B3A5C"/>
                 </a:solidFill>
                 <a:latin typeface="Calibri"/>
               </a:rPr>
@@ -5063,43 +5414,198 @@
               </a:spcAft>
             </a:pPr>
             <a:r>
-              <a:rPr sz="1800">
-                <a:solidFill>
-                  <a:srgbClr val="333333"/>
+              <a:rPr sz="1900" b="1">
+                <a:solidFill>
+                  <a:srgbClr val="C98A1F"/>
+                </a:solidFill>
+                <a:latin typeface="Calibri"/>
+              </a:rPr>
+              <a:t>▸ </a:t>
+            </a:r>
+            <a:r>
+              <a:rPr sz="1900" b="1">
+                <a:solidFill>
+                  <a:srgbClr val="1B3A5C"/>
                 </a:solidFill>
                 <a:latin typeface="Calibri"/>
               </a:rPr>
               <a:t>Next: AST-level rules, enforced tool use, live-provider testing.</a:t>
             </a:r>
           </a:p>
-          <a:p>
-            <a:pPr>
-              <a:spcAft>
-                <a:spcPts val="1000"/>
-              </a:spcAft>
-            </a:pPr>
-            <a:r>
-              <a:rPr sz="1800">
-                <a:solidFill>
-                  <a:srgbClr val="333333"/>
-                </a:solidFill>
-                <a:latin typeface="Calibri"/>
-              </a:rPr>
-              <a:t>Artifact: github.com/mayowa-kalejaiye/Failures — thank you.</a:t>
-            </a:r>
-          </a:p>
-        </p:txBody>
-      </p:sp>
-      <p:sp>
-        <p:nvSpPr>
-          <p:cNvPr id="5" name="TextBox 4"/>
+        </p:txBody>
+      </p:sp>
+      <p:sp>
+        <p:nvSpPr>
+          <p:cNvPr id="8" name="Rounded Rectangle 7"/>
+          <p:cNvSpPr/>
+          <p:nvPr/>
+        </p:nvSpPr>
+        <p:spPr>
+          <a:xfrm>
+            <a:off x="548640" y="4892040"/>
+            <a:ext cx="3520440" cy="566928"/>
+          </a:xfrm>
+          <a:prstGeom prst="roundRect">
+            <a:avLst>
+              <a:gd name="adj" fmla="val 50000"/>
+            </a:avLst>
+          </a:prstGeom>
+          <a:solidFill>
+            <a:srgbClr val="1B3A5C"/>
+          </a:solidFill>
+          <a:ln>
+            <a:noFill/>
+          </a:ln>
+        </p:spPr>
+        <p:style>
+          <a:lnRef idx="1">
+            <a:schemeClr val="accent1"/>
+          </a:lnRef>
+          <a:fillRef idx="3">
+            <a:schemeClr val="accent1"/>
+          </a:fillRef>
+          <a:effectRef idx="2">
+            <a:schemeClr val="accent1"/>
+          </a:effectRef>
+          <a:fontRef idx="minor">
+            <a:schemeClr val="lt1"/>
+          </a:fontRef>
+        </p:style>
+        <p:txBody>
+          <a:bodyPr rtlCol="0" anchor="ctr"/>
+          <a:lstStyle/>
+          <a:p>
+            <a:pPr algn="ctr"/>
+            <a:r>
+              <a:rPr sz="1300">
+                <a:solidFill>
+                  <a:srgbClr val="FFFFFF"/>
+                </a:solidFill>
+                <a:latin typeface="Calibri"/>
+              </a:rPr>
+              <a:t>github.com/mayowa-kalejaiye/Failures</a:t>
+            </a:r>
+          </a:p>
+        </p:txBody>
+      </p:sp>
+      <p:sp>
+        <p:nvSpPr>
+          <p:cNvPr id="9" name="Rounded Rectangle 8"/>
+          <p:cNvSpPr/>
+          <p:nvPr/>
+        </p:nvSpPr>
+        <p:spPr>
+          <a:xfrm>
+            <a:off x="4343400" y="4892040"/>
+            <a:ext cx="3520440" cy="566928"/>
+          </a:xfrm>
+          <a:prstGeom prst="roundRect">
+            <a:avLst>
+              <a:gd name="adj" fmla="val 50000"/>
+            </a:avLst>
+          </a:prstGeom>
+          <a:solidFill>
+            <a:srgbClr val="1B3A5C"/>
+          </a:solidFill>
+          <a:ln>
+            <a:noFill/>
+          </a:ln>
+        </p:spPr>
+        <p:style>
+          <a:lnRef idx="1">
+            <a:schemeClr val="accent1"/>
+          </a:lnRef>
+          <a:fillRef idx="3">
+            <a:schemeClr val="accent1"/>
+          </a:fillRef>
+          <a:effectRef idx="2">
+            <a:schemeClr val="accent1"/>
+          </a:effectRef>
+          <a:fontRef idx="minor">
+            <a:schemeClr val="lt1"/>
+          </a:fontRef>
+        </p:style>
+        <p:txBody>
+          <a:bodyPr rtlCol="0" anchor="ctr"/>
+          <a:lstStyle/>
+          <a:p>
+            <a:pPr algn="ctr"/>
+            <a:r>
+              <a:rPr sz="1300">
+                <a:solidFill>
+                  <a:srgbClr val="FFFFFF"/>
+                </a:solidFill>
+                <a:latin typeface="Calibri"/>
+              </a:rPr>
+              <a:t>doi.org/10.5281/zenodo.22966362</a:t>
+            </a:r>
+          </a:p>
+        </p:txBody>
+      </p:sp>
+      <p:sp>
+        <p:nvSpPr>
+          <p:cNvPr id="10" name="Rounded Rectangle 9"/>
+          <p:cNvSpPr/>
+          <p:nvPr/>
+        </p:nvSpPr>
+        <p:spPr>
+          <a:xfrm>
+            <a:off x="8138160" y="4892040"/>
+            <a:ext cx="3520440" cy="566928"/>
+          </a:xfrm>
+          <a:prstGeom prst="roundRect">
+            <a:avLst>
+              <a:gd name="adj" fmla="val 50000"/>
+            </a:avLst>
+          </a:prstGeom>
+          <a:solidFill>
+            <a:srgbClr val="1B3A5C"/>
+          </a:solidFill>
+          <a:ln>
+            <a:noFill/>
+          </a:ln>
+        </p:spPr>
+        <p:style>
+          <a:lnRef idx="1">
+            <a:schemeClr val="accent1"/>
+          </a:lnRef>
+          <a:fillRef idx="3">
+            <a:schemeClr val="accent1"/>
+          </a:fillRef>
+          <a:effectRef idx="2">
+            <a:schemeClr val="accent1"/>
+          </a:effectRef>
+          <a:fontRef idx="minor">
+            <a:schemeClr val="lt1"/>
+          </a:fontRef>
+        </p:style>
+        <p:txBody>
+          <a:bodyPr rtlCol="0" anchor="ctr"/>
+          <a:lstStyle/>
+          <a:p>
+            <a:pPr algn="ctr"/>
+            <a:r>
+              <a:rPr sz="1300">
+                <a:solidFill>
+                  <a:srgbClr val="FFFFFF"/>
+                </a:solidFill>
+                <a:latin typeface="Calibri"/>
+              </a:rPr>
+              <a:t>failures-mcp on PyPI</a:t>
+            </a:r>
+          </a:p>
+        </p:txBody>
+      </p:sp>
+      <p:sp>
+        <p:nvSpPr>
+          <p:cNvPr id="11" name="TextBox 10"/>
           <p:cNvSpPr txBox="1"/>
           <p:nvPr/>
         </p:nvSpPr>
         <p:spPr>
           <a:xfrm>
-            <a:off x="548640" y="6446520"/>
-            <a:ext cx="11064240" cy="320040"/>
+            <a:off x="548640" y="5669280"/>
+            <a:ext cx="11091672" cy="548640"/>
           </a:xfrm>
           <a:prstGeom prst="rect">
             <a:avLst/>
@@ -5112,14 +5618,15 @@
           </a:bodyPr>
           <a:lstStyle/>
           <a:p>
-            <a:r>
-              <a:rPr sz="1100">
-                <a:solidFill>
-                  <a:srgbClr val="595659"/>
-                </a:solidFill>
-                <a:latin typeface="Calibri"/>
-              </a:rPr>
-              <a:t>Failures — Final Year Project Defence</a:t>
+            <a:pPr algn="ctr"/>
+            <a:r>
+              <a:rPr sz="2200" b="1">
+                <a:solidFill>
+                  <a:srgbClr val="1B3A5C"/>
+                </a:solidFill>
+                <a:latin typeface="Calibri"/>
+              </a:rPr>
+              <a:t>Thank you.</a:t>
             </a:r>
           </a:p>
         </p:txBody>
@@ -5150,8 +5657,8 @@
         </p:nvSpPr>
         <p:spPr>
           <a:xfrm>
-            <a:off x="548640" y="228600"/>
-            <a:ext cx="11064240" cy="914400"/>
+            <a:off x="548640" y="201168"/>
+            <a:ext cx="11064240" cy="292608"/>
           </a:xfrm>
           <a:prstGeom prst="rect">
             <a:avLst/>
@@ -5165,33 +5672,67 @@
           <a:lstStyle/>
           <a:p>
             <a:r>
-              <a:rPr sz="2800" b="1">
-                <a:solidFill>
-                  <a:srgbClr val="1F3864"/>
-                </a:solidFill>
-                <a:latin typeface="Calibri"/>
-              </a:rPr>
-              <a:t>The problem</a:t>
-            </a:r>
-          </a:p>
-        </p:txBody>
-      </p:sp>
-      <p:sp>
-        <p:nvSpPr>
-          <p:cNvPr id="3" name="Rectangle 2"/>
+              <a:rPr sz="1200" b="1">
+                <a:solidFill>
+                  <a:srgbClr val="C98A1F"/>
+                </a:solidFill>
+                <a:latin typeface="Calibri"/>
+              </a:rPr>
+              <a:t>01 · PROBLEM</a:t>
+            </a:r>
+          </a:p>
+        </p:txBody>
+      </p:sp>
+      <p:sp>
+        <p:nvSpPr>
+          <p:cNvPr id="3" name="TextBox 2"/>
+          <p:cNvSpPr txBox="1"/>
+          <p:nvPr/>
+        </p:nvSpPr>
+        <p:spPr>
+          <a:xfrm>
+            <a:off x="548640" y="475488"/>
+            <a:ext cx="11064240" cy="685800"/>
+          </a:xfrm>
+          <a:prstGeom prst="rect">
+            <a:avLst/>
+          </a:prstGeom>
+          <a:noFill/>
+        </p:spPr>
+        <p:txBody>
+          <a:bodyPr wrap="none">
+            <a:spAutoFit/>
+          </a:bodyPr>
+          <a:lstStyle/>
+          <a:p>
+            <a:r>
+              <a:rPr sz="2700" b="1">
+                <a:solidFill>
+                  <a:srgbClr val="1B3A5C"/>
+                </a:solidFill>
+                <a:latin typeface="Calibri"/>
+              </a:rPr>
+              <a:t>Agents write code that runs — not code that survives</a:t>
+            </a:r>
+          </a:p>
+        </p:txBody>
+      </p:sp>
+      <p:sp>
+        <p:nvSpPr>
+          <p:cNvPr id="4" name="Rectangle 3"/>
           <p:cNvSpPr/>
           <p:nvPr/>
         </p:nvSpPr>
         <p:spPr>
           <a:xfrm>
-            <a:off x="548640" y="1051560"/>
-            <a:ext cx="11064240" cy="25400"/>
+            <a:off x="548640" y="1207008"/>
+            <a:ext cx="1463040" cy="38100"/>
           </a:xfrm>
           <a:prstGeom prst="rect">
             <a:avLst/>
           </a:prstGeom>
           <a:solidFill>
-            <a:srgbClr val="1F3864"/>
+            <a:srgbClr val="C98A1F"/>
           </a:solidFill>
           <a:ln>
             <a:noFill/>
@@ -5221,14 +5762,14 @@
       </p:sp>
       <p:sp>
         <p:nvSpPr>
-          <p:cNvPr id="4" name="TextBox 3"/>
+          <p:cNvPr id="5" name="TextBox 4"/>
           <p:cNvSpPr txBox="1"/>
           <p:nvPr/>
         </p:nvSpPr>
         <p:spPr>
           <a:xfrm>
-            <a:off x="548640" y="1371600"/>
-            <a:ext cx="11064240" cy="4754880"/>
+            <a:off x="548640" y="6419088"/>
+            <a:ext cx="11091672" cy="320040"/>
           </a:xfrm>
           <a:prstGeom prst="rect">
             <a:avLst/>
@@ -5241,81 +5782,28 @@
           </a:bodyPr>
           <a:lstStyle/>
           <a:p>
-            <a:pPr>
-              <a:spcAft>
-                <a:spcPts val="1000"/>
-              </a:spcAft>
-            </a:pPr>
-            <a:r>
-              <a:rPr sz="1800">
-                <a:solidFill>
-                  <a:srgbClr val="333333"/>
-                </a:solidFill>
-                <a:latin typeface="Calibri"/>
-              </a:rPr>
-              <a:t>Coding agents write happy-path code: tutorials never show the failure.</a:t>
-            </a:r>
-          </a:p>
-          <a:p>
-            <a:pPr>
-              <a:spcAft>
-                <a:spcPts val="1000"/>
-              </a:spcAft>
-            </a:pPr>
-            <a:r>
-              <a:rPr sz="1800">
-                <a:solidFill>
-                  <a:srgbClr val="333333"/>
-                </a:solidFill>
-                <a:latin typeface="Calibri"/>
-              </a:rPr>
-              <a:t>Benchmarks score correctness on exercised paths, never resilience.</a:t>
-            </a:r>
-          </a:p>
-          <a:p>
-            <a:pPr>
-              <a:spcAft>
-                <a:spcPts val="1000"/>
-              </a:spcAft>
-            </a:pPr>
-            <a:r>
-              <a:rPr sz="1800">
-                <a:solidFill>
-                  <a:srgbClr val="333333"/>
-                </a:solidFill>
-                <a:latin typeface="Calibri"/>
-              </a:rPr>
-              <a:t>Ambiguous outcomes (charged? lost?) become double charges and lost work.</a:t>
-            </a:r>
-          </a:p>
-          <a:p>
-            <a:pPr>
-              <a:spcAft>
-                <a:spcPts val="1000"/>
-              </a:spcAft>
-            </a:pPr>
-            <a:r>
-              <a:rPr sz="1800">
-                <a:solidFill>
-                  <a:srgbClr val="333333"/>
-                </a:solidFill>
-                <a:latin typeface="Calibri"/>
-              </a:rPr>
-              <a:t>No deterministic, evidence-backed guardrails reach agents as tools.</a:t>
-            </a:r>
-          </a:p>
-        </p:txBody>
-      </p:sp>
-      <p:sp>
-        <p:nvSpPr>
-          <p:cNvPr id="5" name="TextBox 4"/>
+            <a:r>
+              <a:rPr sz="1000">
+                <a:solidFill>
+                  <a:srgbClr val="6B6B6B"/>
+                </a:solidFill>
+                <a:latin typeface="Calibri"/>
+              </a:rPr>
+              <a:t>Failures — Final Year Project Defence</a:t>
+            </a:r>
+          </a:p>
+        </p:txBody>
+      </p:sp>
+      <p:sp>
+        <p:nvSpPr>
+          <p:cNvPr id="6" name="TextBox 5"/>
           <p:cNvSpPr txBox="1"/>
           <p:nvPr/>
         </p:nvSpPr>
         <p:spPr>
           <a:xfrm>
-            <a:off x="548640" y="6446520"/>
-            <a:ext cx="11064240" cy="320040"/>
+            <a:off x="10424160" y="6419088"/>
+            <a:ext cx="1216152" cy="320040"/>
           </a:xfrm>
           <a:prstGeom prst="rect">
             <a:avLst/>
@@ -5328,14 +5816,216 @@
           </a:bodyPr>
           <a:lstStyle/>
           <a:p>
-            <a:r>
-              <a:rPr sz="1100">
-                <a:solidFill>
-                  <a:srgbClr val="595659"/>
-                </a:solidFill>
-                <a:latin typeface="Calibri"/>
-              </a:rPr>
-              <a:t>Failures — Final Year Project Defence</a:t>
+            <a:pPr algn="r"/>
+            <a:r>
+              <a:rPr sz="1000">
+                <a:solidFill>
+                  <a:srgbClr val="6B6B6B"/>
+                </a:solidFill>
+                <a:latin typeface="Calibri"/>
+              </a:rPr>
+              <a:t>02 / 11</a:t>
+            </a:r>
+          </a:p>
+        </p:txBody>
+      </p:sp>
+      <p:sp>
+        <p:nvSpPr>
+          <p:cNvPr id="7" name="TextBox 6"/>
+          <p:cNvSpPr txBox="1"/>
+          <p:nvPr/>
+        </p:nvSpPr>
+        <p:spPr>
+          <a:xfrm>
+            <a:off x="548640" y="1508760"/>
+            <a:ext cx="11091672" cy="4023360"/>
+          </a:xfrm>
+          <a:prstGeom prst="rect">
+            <a:avLst/>
+          </a:prstGeom>
+          <a:noFill/>
+        </p:spPr>
+        <p:txBody>
+          <a:bodyPr wrap="none">
+            <a:spAutoFit/>
+          </a:bodyPr>
+          <a:lstStyle/>
+          <a:p>
+            <a:pPr>
+              <a:spcAft>
+                <a:spcPts val="1200"/>
+              </a:spcAft>
+            </a:pPr>
+            <a:r>
+              <a:rPr sz="1900" b="1">
+                <a:solidFill>
+                  <a:srgbClr val="C98A1F"/>
+                </a:solidFill>
+                <a:latin typeface="Calibri"/>
+              </a:rPr>
+              <a:t>▸ </a:t>
+            </a:r>
+            <a:r>
+              <a:rPr sz="1900" b="1">
+                <a:solidFill>
+                  <a:srgbClr val="1B3A5C"/>
+                </a:solidFill>
+                <a:latin typeface="Calibri"/>
+              </a:rPr>
+              <a:t>Coding agents learn from tutorials, which never show the failure.</a:t>
+            </a:r>
+          </a:p>
+          <a:p>
+            <a:pPr>
+              <a:spcAft>
+                <a:spcPts val="1200"/>
+              </a:spcAft>
+            </a:pPr>
+            <a:r>
+              <a:rPr sz="1900" b="1">
+                <a:solidFill>
+                  <a:srgbClr val="C98A1F"/>
+                </a:solidFill>
+                <a:latin typeface="Calibri"/>
+              </a:rPr>
+              <a:t>▸ </a:t>
+            </a:r>
+            <a:r>
+              <a:rPr sz="1900" b="1">
+                <a:solidFill>
+                  <a:srgbClr val="1B3A5C"/>
+                </a:solidFill>
+                <a:latin typeface="Calibri"/>
+              </a:rPr>
+              <a:t>Benchmarks score correctness on exercised paths — never resilience.</a:t>
+            </a:r>
+          </a:p>
+          <a:p>
+            <a:pPr>
+              <a:spcAft>
+                <a:spcPts val="1200"/>
+              </a:spcAft>
+            </a:pPr>
+            <a:r>
+              <a:rPr sz="1900" b="1">
+                <a:solidFill>
+                  <a:srgbClr val="C98A1F"/>
+                </a:solidFill>
+                <a:latin typeface="Calibri"/>
+              </a:rPr>
+              <a:t>▸ </a:t>
+            </a:r>
+            <a:r>
+              <a:rPr sz="1900" b="1">
+                <a:solidFill>
+                  <a:srgbClr val="1B3A5C"/>
+                </a:solidFill>
+                <a:latin typeface="Calibri"/>
+              </a:rPr>
+              <a:t>Ambiguous outcomes (charged? lost?) become double charges and lost work.</a:t>
+            </a:r>
+          </a:p>
+          <a:p>
+            <a:pPr>
+              <a:spcAft>
+                <a:spcPts val="1200"/>
+              </a:spcAft>
+            </a:pPr>
+            <a:r>
+              <a:rPr sz="1900" b="1">
+                <a:solidFill>
+                  <a:srgbClr val="C98A1F"/>
+                </a:solidFill>
+                <a:latin typeface="Calibri"/>
+              </a:rPr>
+              <a:t>▸ </a:t>
+            </a:r>
+            <a:r>
+              <a:rPr sz="1900" b="1">
+                <a:solidFill>
+                  <a:srgbClr val="1B3A5C"/>
+                </a:solidFill>
+                <a:latin typeface="Calibri"/>
+              </a:rPr>
+              <a:t>No deterministic, evidence-backed guardrails reach agents as tools.</a:t>
+            </a:r>
+          </a:p>
+        </p:txBody>
+      </p:sp>
+      <p:sp>
+        <p:nvSpPr>
+          <p:cNvPr id="8" name="Rectangle 7"/>
+          <p:cNvSpPr/>
+          <p:nvPr/>
+        </p:nvSpPr>
+        <p:spPr>
+          <a:xfrm>
+            <a:off x="548640" y="5806440"/>
+            <a:ext cx="11091672" cy="502920"/>
+          </a:xfrm>
+          <a:prstGeom prst="rect">
+            <a:avLst/>
+          </a:prstGeom>
+          <a:solidFill>
+            <a:srgbClr val="FDF3E3"/>
+          </a:solidFill>
+          <a:ln>
+            <a:noFill/>
+          </a:ln>
+        </p:spPr>
+        <p:style>
+          <a:lnRef idx="1">
+            <a:schemeClr val="accent1"/>
+          </a:lnRef>
+          <a:fillRef idx="3">
+            <a:schemeClr val="accent1"/>
+          </a:fillRef>
+          <a:effectRef idx="2">
+            <a:schemeClr val="accent1"/>
+          </a:effectRef>
+          <a:fontRef idx="minor">
+            <a:schemeClr val="lt1"/>
+          </a:fontRef>
+        </p:style>
+        <p:txBody>
+          <a:bodyPr rtlCol="0" anchor="ctr"/>
+          <a:lstStyle/>
+          <a:p>
+            <a:pPr algn="ctr"/>
+          </a:p>
+        </p:txBody>
+      </p:sp>
+      <p:sp>
+        <p:nvSpPr>
+          <p:cNvPr id="9" name="TextBox 8"/>
+          <p:cNvSpPr txBox="1"/>
+          <p:nvPr/>
+        </p:nvSpPr>
+        <p:spPr>
+          <a:xfrm>
+            <a:off x="777240" y="5833872"/>
+            <a:ext cx="10607040" cy="457200"/>
+          </a:xfrm>
+          <a:prstGeom prst="rect">
+            <a:avLst/>
+          </a:prstGeom>
+          <a:noFill/>
+        </p:spPr>
+        <p:txBody>
+          <a:bodyPr wrap="none">
+            <a:spAutoFit/>
+          </a:bodyPr>
+          <a:lstStyle/>
+          <a:p>
+            <a:pPr algn="l"/>
+            <a:r>
+              <a:rPr sz="1300" i="1">
+                <a:solidFill>
+                  <a:srgbClr val="1B3A5C"/>
+                </a:solidFill>
+                <a:latin typeface="Calibri"/>
+              </a:rPr>
+              <a:t>A payment handler that passes every test and double-charges on retry is a success under every standard metric.</a:t>
             </a:r>
           </a:p>
         </p:txBody>
@@ -5366,8 +6056,8 @@
         </p:nvSpPr>
         <p:spPr>
           <a:xfrm>
-            <a:off x="548640" y="228600"/>
-            <a:ext cx="11064240" cy="914400"/>
+            <a:off x="548640" y="201168"/>
+            <a:ext cx="11064240" cy="292608"/>
           </a:xfrm>
           <a:prstGeom prst="rect">
             <a:avLst/>
@@ -5381,33 +6071,67 @@
           <a:lstStyle/>
           <a:p>
             <a:r>
-              <a:rPr sz="2800" b="1">
-                <a:solidFill>
-                  <a:srgbClr val="1F3864"/>
-                </a:solidFill>
-                <a:latin typeface="Calibri"/>
-              </a:rPr>
-              <a:t>Aim and objectives</a:t>
-            </a:r>
-          </a:p>
-        </p:txBody>
-      </p:sp>
-      <p:sp>
-        <p:nvSpPr>
-          <p:cNvPr id="3" name="Rectangle 2"/>
+              <a:rPr sz="1200" b="1">
+                <a:solidFill>
+                  <a:srgbClr val="C98A1F"/>
+                </a:solidFill>
+                <a:latin typeface="Calibri"/>
+              </a:rPr>
+              <a:t>02 · AIM</a:t>
+            </a:r>
+          </a:p>
+        </p:txBody>
+      </p:sp>
+      <p:sp>
+        <p:nvSpPr>
+          <p:cNvPr id="3" name="TextBox 2"/>
+          <p:cNvSpPr txBox="1"/>
+          <p:nvPr/>
+        </p:nvSpPr>
+        <p:spPr>
+          <a:xfrm>
+            <a:off x="548640" y="475488"/>
+            <a:ext cx="11064240" cy="685800"/>
+          </a:xfrm>
+          <a:prstGeom prst="rect">
+            <a:avLst/>
+          </a:prstGeom>
+          <a:noFill/>
+        </p:spPr>
+        <p:txBody>
+          <a:bodyPr wrap="none">
+            <a:spAutoFit/>
+          </a:bodyPr>
+          <a:lstStyle/>
+          <a:p>
+            <a:r>
+              <a:rPr sz="2700" b="1">
+                <a:solidFill>
+                  <a:srgbClr val="1B3A5C"/>
+                </a:solidFill>
+                <a:latin typeface="Calibri"/>
+              </a:rPr>
+              <a:t>Build the checking layer benchmarks never built</a:t>
+            </a:r>
+          </a:p>
+        </p:txBody>
+      </p:sp>
+      <p:sp>
+        <p:nvSpPr>
+          <p:cNvPr id="4" name="Rectangle 3"/>
           <p:cNvSpPr/>
           <p:nvPr/>
         </p:nvSpPr>
         <p:spPr>
           <a:xfrm>
-            <a:off x="548640" y="1051560"/>
-            <a:ext cx="11064240" cy="25400"/>
+            <a:off x="548640" y="1207008"/>
+            <a:ext cx="1463040" cy="38100"/>
           </a:xfrm>
           <a:prstGeom prst="rect">
             <a:avLst/>
           </a:prstGeom>
           <a:solidFill>
-            <a:srgbClr val="1F3864"/>
+            <a:srgbClr val="C98A1F"/>
           </a:solidFill>
           <a:ln>
             <a:noFill/>
@@ -5437,14 +6161,14 @@
       </p:sp>
       <p:sp>
         <p:nvSpPr>
-          <p:cNvPr id="4" name="TextBox 3"/>
+          <p:cNvPr id="5" name="TextBox 4"/>
           <p:cNvSpPr txBox="1"/>
           <p:nvPr/>
         </p:nvSpPr>
         <p:spPr>
           <a:xfrm>
-            <a:off x="548640" y="1371600"/>
-            <a:ext cx="11064240" cy="4754880"/>
+            <a:off x="548640" y="6419088"/>
+            <a:ext cx="11091672" cy="320040"/>
           </a:xfrm>
           <a:prstGeom prst="rect">
             <a:avLst/>
@@ -5457,113 +6181,28 @@
           </a:bodyPr>
           <a:lstStyle/>
           <a:p>
-            <a:pPr>
-              <a:spcAft>
-                <a:spcPts val="1000"/>
-              </a:spcAft>
-            </a:pPr>
-            <a:r>
-              <a:rPr sz="1800">
-                <a:solidFill>
-                  <a:srgbClr val="333333"/>
-                </a:solidFill>
-                <a:latin typeface="Calibri"/>
-              </a:rPr>
-              <a:t>Aim: design, implement, and evaluate deterministic failure-mode guardrails for AI-generated software.</a:t>
-            </a:r>
-          </a:p>
-          <a:p>
-            <a:pPr>
-              <a:spcAft>
-                <a:spcPts val="1000"/>
-              </a:spcAft>
-            </a:pPr>
-            <a:r>
-              <a:rPr sz="1800">
-                <a:solidFill>
-                  <a:srgbClr val="333333"/>
-                </a:solidFill>
-                <a:latin typeface="Calibri"/>
-              </a:rPr>
-              <a:t>1. Investigate failure modes and existing guardrail approaches.</a:t>
-            </a:r>
-          </a:p>
-          <a:p>
-            <a:pPr>
-              <a:spcAft>
-                <a:spcPts val="1000"/>
-              </a:spcAft>
-            </a:pPr>
-            <a:r>
-              <a:rPr sz="1800">
-                <a:solidFill>
-                  <a:srgbClr val="333333"/>
-                </a:solidFill>
-                <a:latin typeface="Calibri"/>
-              </a:rPr>
-              <a:t>2. Design an invariant-based guardrail framework.</a:t>
-            </a:r>
-          </a:p>
-          <a:p>
-            <a:pPr>
-              <a:spcAft>
-                <a:spcPts val="1000"/>
-              </a:spcAft>
-            </a:pPr>
-            <a:r>
-              <a:rPr sz="1800">
-                <a:solidFill>
-                  <a:srgbClr val="333333"/>
-                </a:solidFill>
-                <a:latin typeface="Calibri"/>
-              </a:rPr>
-              <a:t>3. Develop it as a Model Context Protocol server.</a:t>
-            </a:r>
-          </a:p>
-          <a:p>
-            <a:pPr>
-              <a:spcAft>
-                <a:spcPts val="1000"/>
-              </a:spcAft>
-            </a:pPr>
-            <a:r>
-              <a:rPr sz="1800">
-                <a:solidFill>
-                  <a:srgbClr val="333333"/>
-                </a:solidFill>
-                <a:latin typeface="Calibri"/>
-              </a:rPr>
-              <a:t>4. Implement a deterministic evaluation harness.</a:t>
-            </a:r>
-          </a:p>
-          <a:p>
-            <a:pPr>
-              <a:spcAft>
-                <a:spcPts val="1000"/>
-              </a:spcAft>
-            </a:pPr>
-            <a:r>
-              <a:rPr sz="1800">
-                <a:solidFill>
-                  <a:srgbClr val="333333"/>
-                </a:solidFill>
-                <a:latin typeface="Calibri"/>
-              </a:rPr>
-              <a:t>5. Evaluate through proxy and blind agent studies.</a:t>
-            </a:r>
-          </a:p>
-        </p:txBody>
-      </p:sp>
-      <p:sp>
-        <p:nvSpPr>
-          <p:cNvPr id="5" name="TextBox 4"/>
+            <a:r>
+              <a:rPr sz="1000">
+                <a:solidFill>
+                  <a:srgbClr val="6B6B6B"/>
+                </a:solidFill>
+                <a:latin typeface="Calibri"/>
+              </a:rPr>
+              <a:t>Failures — Final Year Project Defence</a:t>
+            </a:r>
+          </a:p>
+        </p:txBody>
+      </p:sp>
+      <p:sp>
+        <p:nvSpPr>
+          <p:cNvPr id="6" name="TextBox 5"/>
           <p:cNvSpPr txBox="1"/>
           <p:nvPr/>
         </p:nvSpPr>
         <p:spPr>
           <a:xfrm>
-            <a:off x="548640" y="6446520"/>
-            <a:ext cx="11064240" cy="320040"/>
+            <a:off x="10424160" y="6419088"/>
+            <a:ext cx="1216152" cy="320040"/>
           </a:xfrm>
           <a:prstGeom prst="rect">
             <a:avLst/>
@@ -5576,14 +6215,188 @@
           </a:bodyPr>
           <a:lstStyle/>
           <a:p>
-            <a:r>
-              <a:rPr sz="1100">
-                <a:solidFill>
-                  <a:srgbClr val="595659"/>
-                </a:solidFill>
-                <a:latin typeface="Calibri"/>
-              </a:rPr>
-              <a:t>Failures — Final Year Project Defence</a:t>
+            <a:pPr algn="r"/>
+            <a:r>
+              <a:rPr sz="1000">
+                <a:solidFill>
+                  <a:srgbClr val="6B6B6B"/>
+                </a:solidFill>
+                <a:latin typeface="Calibri"/>
+              </a:rPr>
+              <a:t>03 / 11</a:t>
+            </a:r>
+          </a:p>
+        </p:txBody>
+      </p:sp>
+      <p:sp>
+        <p:nvSpPr>
+          <p:cNvPr id="7" name="TextBox 6"/>
+          <p:cNvSpPr txBox="1"/>
+          <p:nvPr/>
+        </p:nvSpPr>
+        <p:spPr>
+          <a:xfrm>
+            <a:off x="548640" y="1508760"/>
+            <a:ext cx="11091672" cy="4480560"/>
+          </a:xfrm>
+          <a:prstGeom prst="rect">
+            <a:avLst/>
+          </a:prstGeom>
+          <a:noFill/>
+        </p:spPr>
+        <p:txBody>
+          <a:bodyPr wrap="none">
+            <a:spAutoFit/>
+          </a:bodyPr>
+          <a:lstStyle/>
+          <a:p>
+            <a:pPr>
+              <a:spcAft>
+                <a:spcPts val="900"/>
+              </a:spcAft>
+            </a:pPr>
+            <a:r>
+              <a:rPr sz="1800" b="1">
+                <a:solidFill>
+                  <a:srgbClr val="C98A1F"/>
+                </a:solidFill>
+                <a:latin typeface="Calibri"/>
+              </a:rPr>
+              <a:t>▸ </a:t>
+            </a:r>
+            <a:r>
+              <a:rPr sz="1800" b="1">
+                <a:solidFill>
+                  <a:srgbClr val="1B3A5C"/>
+                </a:solidFill>
+                <a:latin typeface="Calibri"/>
+              </a:rPr>
+              <a:t>Aim: design, implement, and evaluate deterministic failure-mode guardrails for AI-generated software.</a:t>
+            </a:r>
+          </a:p>
+          <a:p>
+            <a:pPr>
+              <a:spcAft>
+                <a:spcPts val="900"/>
+              </a:spcAft>
+            </a:pPr>
+            <a:r>
+              <a:rPr sz="1800" b="1">
+                <a:solidFill>
+                  <a:srgbClr val="C98A1F"/>
+                </a:solidFill>
+                <a:latin typeface="Calibri"/>
+              </a:rPr>
+              <a:t>▸ </a:t>
+            </a:r>
+            <a:r>
+              <a:rPr sz="1800">
+                <a:solidFill>
+                  <a:srgbClr val="262626"/>
+                </a:solidFill>
+                <a:latin typeface="Calibri"/>
+              </a:rPr>
+              <a:t>1. Investigate failure modes and existing guardrail approaches.</a:t>
+            </a:r>
+          </a:p>
+          <a:p>
+            <a:pPr>
+              <a:spcAft>
+                <a:spcPts val="900"/>
+              </a:spcAft>
+            </a:pPr>
+            <a:r>
+              <a:rPr sz="1800" b="1">
+                <a:solidFill>
+                  <a:srgbClr val="C98A1F"/>
+                </a:solidFill>
+                <a:latin typeface="Calibri"/>
+              </a:rPr>
+              <a:t>▸ </a:t>
+            </a:r>
+            <a:r>
+              <a:rPr sz="1800">
+                <a:solidFill>
+                  <a:srgbClr val="262626"/>
+                </a:solidFill>
+                <a:latin typeface="Calibri"/>
+              </a:rPr>
+              <a:t>2. Design an invariant-based guardrail framework.</a:t>
+            </a:r>
+          </a:p>
+          <a:p>
+            <a:pPr>
+              <a:spcAft>
+                <a:spcPts val="900"/>
+              </a:spcAft>
+            </a:pPr>
+            <a:r>
+              <a:rPr sz="1800" b="1">
+                <a:solidFill>
+                  <a:srgbClr val="C98A1F"/>
+                </a:solidFill>
+                <a:latin typeface="Calibri"/>
+              </a:rPr>
+              <a:t>▸ </a:t>
+            </a:r>
+            <a:r>
+              <a:rPr sz="1800" b="1">
+                <a:solidFill>
+                  <a:srgbClr val="1B3A5C"/>
+                </a:solidFill>
+                <a:latin typeface="Calibri"/>
+              </a:rPr>
+              <a:t>3. Develop it as a Model Context Protocol server.</a:t>
+            </a:r>
+          </a:p>
+          <a:p>
+            <a:pPr>
+              <a:spcAft>
+                <a:spcPts val="900"/>
+              </a:spcAft>
+            </a:pPr>
+            <a:r>
+              <a:rPr sz="1800" b="1">
+                <a:solidFill>
+                  <a:srgbClr val="C98A1F"/>
+                </a:solidFill>
+                <a:latin typeface="Calibri"/>
+              </a:rPr>
+              <a:t>▸ </a:t>
+            </a:r>
+            <a:r>
+              <a:rPr sz="1800" b="1">
+                <a:solidFill>
+                  <a:srgbClr val="1B3A5C"/>
+                </a:solidFill>
+                <a:latin typeface="Calibri"/>
+              </a:rPr>
+              <a:t>4. Implement a deterministic evaluation harness.</a:t>
+            </a:r>
+          </a:p>
+          <a:p>
+            <a:pPr>
+              <a:spcAft>
+                <a:spcPts val="900"/>
+              </a:spcAft>
+            </a:pPr>
+            <a:r>
+              <a:rPr sz="1800" b="1">
+                <a:solidFill>
+                  <a:srgbClr val="C98A1F"/>
+                </a:solidFill>
+                <a:latin typeface="Calibri"/>
+              </a:rPr>
+              <a:t>▸ </a:t>
+            </a:r>
+            <a:r>
+              <a:rPr sz="1800" b="1">
+                <a:solidFill>
+                  <a:srgbClr val="1B3A5C"/>
+                </a:solidFill>
+                <a:latin typeface="Calibri"/>
+              </a:rPr>
+              <a:t>5. Evaluate through proxy and blind agent studies.</a:t>
             </a:r>
           </a:p>
         </p:txBody>
@@ -5614,8 +6427,8 @@
         </p:nvSpPr>
         <p:spPr>
           <a:xfrm>
-            <a:off x="548640" y="228600"/>
-            <a:ext cx="11064240" cy="914400"/>
+            <a:off x="548640" y="201168"/>
+            <a:ext cx="11064240" cy="292608"/>
           </a:xfrm>
           <a:prstGeom prst="rect">
             <a:avLst/>
@@ -5629,33 +6442,67 @@
           <a:lstStyle/>
           <a:p>
             <a:r>
-              <a:rPr sz="2800" b="1">
-                <a:solidFill>
-                  <a:srgbClr val="1F3864"/>
-                </a:solidFill>
-                <a:latin typeface="Calibri"/>
-              </a:rPr>
-              <a:t>Literature and the gap</a:t>
-            </a:r>
-          </a:p>
-        </p:txBody>
-      </p:sp>
-      <p:sp>
-        <p:nvSpPr>
-          <p:cNvPr id="3" name="Rectangle 2"/>
+              <a:rPr sz="1200" b="1">
+                <a:solidFill>
+                  <a:srgbClr val="C98A1F"/>
+                </a:solidFill>
+                <a:latin typeface="Calibri"/>
+              </a:rPr>
+              <a:t>03 · LITERATURE</a:t>
+            </a:r>
+          </a:p>
+        </p:txBody>
+      </p:sp>
+      <p:sp>
+        <p:nvSpPr>
+          <p:cNvPr id="3" name="TextBox 2"/>
+          <p:cNvSpPr txBox="1"/>
+          <p:nvPr/>
+        </p:nvSpPr>
+        <p:spPr>
+          <a:xfrm>
+            <a:off x="548640" y="475488"/>
+            <a:ext cx="11064240" cy="685800"/>
+          </a:xfrm>
+          <a:prstGeom prst="rect">
+            <a:avLst/>
+          </a:prstGeom>
+          <a:noFill/>
+        </p:spPr>
+        <p:txBody>
+          <a:bodyPr wrap="none">
+            <a:spAutoFit/>
+          </a:bodyPr>
+          <a:lstStyle/>
+          <a:p>
+            <a:r>
+              <a:rPr sz="2700" b="1">
+                <a:solidFill>
+                  <a:srgbClr val="1B3A5C"/>
+                </a:solidFill>
+                <a:latin typeface="Calibri"/>
+              </a:rPr>
+              <a:t>Everything exists except the connection</a:t>
+            </a:r>
+          </a:p>
+        </p:txBody>
+      </p:sp>
+      <p:sp>
+        <p:nvSpPr>
+          <p:cNvPr id="4" name="Rectangle 3"/>
           <p:cNvSpPr/>
           <p:nvPr/>
         </p:nvSpPr>
         <p:spPr>
           <a:xfrm>
-            <a:off x="548640" y="1051560"/>
-            <a:ext cx="11064240" cy="25400"/>
+            <a:off x="548640" y="1207008"/>
+            <a:ext cx="1463040" cy="38100"/>
           </a:xfrm>
           <a:prstGeom prst="rect">
             <a:avLst/>
           </a:prstGeom>
           <a:solidFill>
-            <a:srgbClr val="1F3864"/>
+            <a:srgbClr val="C98A1F"/>
           </a:solidFill>
           <a:ln>
             <a:noFill/>
@@ -5685,14 +6532,14 @@
       </p:sp>
       <p:sp>
         <p:nvSpPr>
-          <p:cNvPr id="4" name="TextBox 3"/>
+          <p:cNvPr id="5" name="TextBox 4"/>
           <p:cNvSpPr txBox="1"/>
           <p:nvPr/>
         </p:nvSpPr>
         <p:spPr>
           <a:xfrm>
-            <a:off x="548640" y="1371600"/>
-            <a:ext cx="11064240" cy="4754880"/>
+            <a:off x="548640" y="6419088"/>
+            <a:ext cx="11091672" cy="320040"/>
           </a:xfrm>
           <a:prstGeom prst="rect">
             <a:avLst/>
@@ -5705,81 +6552,28 @@
           </a:bodyPr>
           <a:lstStyle/>
           <a:p>
-            <a:pPr>
-              <a:spcAft>
-                <a:spcPts val="1000"/>
-              </a:spcAft>
-            </a:pPr>
-            <a:r>
-              <a:rPr sz="1800">
-                <a:solidFill>
-                  <a:srgbClr val="333333"/>
-                </a:solidFill>
-                <a:latin typeface="Calibri"/>
-              </a:rPr>
-              <a:t>What exists: correctness benchmarks, pattern-selection DSS, resilience canons.</a:t>
-            </a:r>
-          </a:p>
-          <a:p>
-            <a:pPr>
-              <a:spcAft>
-                <a:spcPts val="1000"/>
-              </a:spcAft>
-            </a:pPr>
-            <a:r>
-              <a:rPr sz="1800">
-                <a:solidFill>
-                  <a:srgbClr val="333333"/>
-                </a:solidFill>
-                <a:latin typeface="Calibri"/>
-              </a:rPr>
-              <a:t>What is missing: checks on failure properties of generated code.</a:t>
-            </a:r>
-          </a:p>
-          <a:p>
-            <a:pPr>
-              <a:spcAft>
-                <a:spcPts val="1000"/>
-              </a:spcAft>
-            </a:pPr>
-            <a:r>
-              <a:rPr sz="1800">
-                <a:solidFill>
-                  <a:srgbClr val="333333"/>
-                </a:solidFill>
-                <a:latin typeface="Calibri"/>
-              </a:rPr>
-              <a:t>Nobody connects deterministic guardrails to the agents producing the code.</a:t>
-            </a:r>
-          </a:p>
-          <a:p>
-            <a:pPr>
-              <a:spcAft>
-                <a:spcPts val="1000"/>
-              </a:spcAft>
-            </a:pPr>
-            <a:r>
-              <a:rPr sz="1800">
-                <a:solidFill>
-                  <a:srgbClr val="333333"/>
-                </a:solidFill>
-                <a:latin typeface="Calibri"/>
-              </a:rPr>
-              <a:t>Therefore this study builds and measures that connection.</a:t>
-            </a:r>
-          </a:p>
-        </p:txBody>
-      </p:sp>
-      <p:sp>
-        <p:nvSpPr>
-          <p:cNvPr id="5" name="TextBox 4"/>
+            <a:r>
+              <a:rPr sz="1000">
+                <a:solidFill>
+                  <a:srgbClr val="6B6B6B"/>
+                </a:solidFill>
+                <a:latin typeface="Calibri"/>
+              </a:rPr>
+              <a:t>Failures — Final Year Project Defence</a:t>
+            </a:r>
+          </a:p>
+        </p:txBody>
+      </p:sp>
+      <p:sp>
+        <p:nvSpPr>
+          <p:cNvPr id="6" name="TextBox 5"/>
           <p:cNvSpPr txBox="1"/>
           <p:nvPr/>
         </p:nvSpPr>
         <p:spPr>
           <a:xfrm>
-            <a:off x="548640" y="6446520"/>
-            <a:ext cx="11064240" cy="320040"/>
+            <a:off x="10424160" y="6419088"/>
+            <a:ext cx="1216152" cy="320040"/>
           </a:xfrm>
           <a:prstGeom prst="rect">
             <a:avLst/>
@@ -5792,14 +6586,216 @@
           </a:bodyPr>
           <a:lstStyle/>
           <a:p>
-            <a:r>
-              <a:rPr sz="1100">
-                <a:solidFill>
-                  <a:srgbClr val="595659"/>
-                </a:solidFill>
-                <a:latin typeface="Calibri"/>
-              </a:rPr>
-              <a:t>Failures — Final Year Project Defence</a:t>
+            <a:pPr algn="r"/>
+            <a:r>
+              <a:rPr sz="1000">
+                <a:solidFill>
+                  <a:srgbClr val="6B6B6B"/>
+                </a:solidFill>
+                <a:latin typeface="Calibri"/>
+              </a:rPr>
+              <a:t>04 / 11</a:t>
+            </a:r>
+          </a:p>
+        </p:txBody>
+      </p:sp>
+      <p:sp>
+        <p:nvSpPr>
+          <p:cNvPr id="7" name="TextBox 6"/>
+          <p:cNvSpPr txBox="1"/>
+          <p:nvPr/>
+        </p:nvSpPr>
+        <p:spPr>
+          <a:xfrm>
+            <a:off x="548640" y="1508760"/>
+            <a:ext cx="11091672" cy="4023360"/>
+          </a:xfrm>
+          <a:prstGeom prst="rect">
+            <a:avLst/>
+          </a:prstGeom>
+          <a:noFill/>
+        </p:spPr>
+        <p:txBody>
+          <a:bodyPr wrap="none">
+            <a:spAutoFit/>
+          </a:bodyPr>
+          <a:lstStyle/>
+          <a:p>
+            <a:pPr>
+              <a:spcAft>
+                <a:spcPts val="1200"/>
+              </a:spcAft>
+            </a:pPr>
+            <a:r>
+              <a:rPr sz="1900" b="1">
+                <a:solidFill>
+                  <a:srgbClr val="C98A1F"/>
+                </a:solidFill>
+                <a:latin typeface="Calibri"/>
+              </a:rPr>
+              <a:t>▸ </a:t>
+            </a:r>
+            <a:r>
+              <a:rPr sz="1900" b="1">
+                <a:solidFill>
+                  <a:srgbClr val="1B3A5C"/>
+                </a:solidFill>
+                <a:latin typeface="Calibri"/>
+              </a:rPr>
+              <a:t>Correctness benchmarks (HumanEval, SWE-bench) never score resilience.</a:t>
+            </a:r>
+          </a:p>
+          <a:p>
+            <a:pPr>
+              <a:spcAft>
+                <a:spcPts val="1200"/>
+              </a:spcAft>
+            </a:pPr>
+            <a:r>
+              <a:rPr sz="1900" b="1">
+                <a:solidFill>
+                  <a:srgbClr val="C98A1F"/>
+                </a:solidFill>
+                <a:latin typeface="Calibri"/>
+              </a:rPr>
+              <a:t>▸ </a:t>
+            </a:r>
+            <a:r>
+              <a:rPr sz="1900" b="1">
+                <a:solidFill>
+                  <a:srgbClr val="1B3A5C"/>
+                </a:solidFill>
+                <a:latin typeface="Calibri"/>
+              </a:rPr>
+              <a:t>Pattern-selection DSS compare technologies — they never check generated code.</a:t>
+            </a:r>
+          </a:p>
+          <a:p>
+            <a:pPr>
+              <a:spcAft>
+                <a:spcPts val="1200"/>
+              </a:spcAft>
+            </a:pPr>
+            <a:r>
+              <a:rPr sz="1900" b="1">
+                <a:solidFill>
+                  <a:srgbClr val="C98A1F"/>
+                </a:solidFill>
+                <a:latin typeface="Calibri"/>
+              </a:rPr>
+              <a:t>▸ </a:t>
+            </a:r>
+            <a:r>
+              <a:rPr sz="1900" b="1">
+                <a:solidFill>
+                  <a:srgbClr val="1B3A5C"/>
+                </a:solidFill>
+                <a:latin typeface="Calibri"/>
+              </a:rPr>
+              <a:t>Resilience canons catalogue controls as knowledge, not as checks.</a:t>
+            </a:r>
+          </a:p>
+          <a:p>
+            <a:pPr>
+              <a:spcAft>
+                <a:spcPts val="1200"/>
+              </a:spcAft>
+            </a:pPr>
+            <a:r>
+              <a:rPr sz="1900" b="1">
+                <a:solidFill>
+                  <a:srgbClr val="C98A1F"/>
+                </a:solidFill>
+                <a:latin typeface="Calibri"/>
+              </a:rPr>
+              <a:t>▸ </a:t>
+            </a:r>
+            <a:r>
+              <a:rPr sz="1900" b="1">
+                <a:solidFill>
+                  <a:srgbClr val="1B3A5C"/>
+                </a:solidFill>
+                <a:latin typeface="Calibri"/>
+              </a:rPr>
+              <a:t>Gap: nobody connects deterministic guardrails to the agents producing the code.</a:t>
+            </a:r>
+          </a:p>
+        </p:txBody>
+      </p:sp>
+      <p:sp>
+        <p:nvSpPr>
+          <p:cNvPr id="8" name="Rectangle 7"/>
+          <p:cNvSpPr/>
+          <p:nvPr/>
+        </p:nvSpPr>
+        <p:spPr>
+          <a:xfrm>
+            <a:off x="548640" y="5806440"/>
+            <a:ext cx="11091672" cy="502920"/>
+          </a:xfrm>
+          <a:prstGeom prst="rect">
+            <a:avLst/>
+          </a:prstGeom>
+          <a:solidFill>
+            <a:srgbClr val="FDF3E3"/>
+          </a:solidFill>
+          <a:ln>
+            <a:noFill/>
+          </a:ln>
+        </p:spPr>
+        <p:style>
+          <a:lnRef idx="1">
+            <a:schemeClr val="accent1"/>
+          </a:lnRef>
+          <a:fillRef idx="3">
+            <a:schemeClr val="accent1"/>
+          </a:fillRef>
+          <a:effectRef idx="2">
+            <a:schemeClr val="accent1"/>
+          </a:effectRef>
+          <a:fontRef idx="minor">
+            <a:schemeClr val="lt1"/>
+          </a:fontRef>
+        </p:style>
+        <p:txBody>
+          <a:bodyPr rtlCol="0" anchor="ctr"/>
+          <a:lstStyle/>
+          <a:p>
+            <a:pPr algn="ctr"/>
+          </a:p>
+        </p:txBody>
+      </p:sp>
+      <p:sp>
+        <p:nvSpPr>
+          <p:cNvPr id="9" name="TextBox 8"/>
+          <p:cNvSpPr txBox="1"/>
+          <p:nvPr/>
+        </p:nvSpPr>
+        <p:spPr>
+          <a:xfrm>
+            <a:off x="777240" y="5833872"/>
+            <a:ext cx="10607040" cy="457200"/>
+          </a:xfrm>
+          <a:prstGeom prst="rect">
+            <a:avLst/>
+          </a:prstGeom>
+          <a:noFill/>
+        </p:spPr>
+        <p:txBody>
+          <a:bodyPr wrap="none">
+            <a:spAutoFit/>
+          </a:bodyPr>
+          <a:lstStyle/>
+          <a:p>
+            <a:pPr algn="l"/>
+            <a:r>
+              <a:rPr sz="1300" i="1">
+                <a:solidFill>
+                  <a:srgbClr val="1B3A5C"/>
+                </a:solidFill>
+                <a:latin typeface="Calibri"/>
+              </a:rPr>
+              <a:t>Done A, B, C — but none done D. Therefore propose E.</a:t>
             </a:r>
           </a:p>
         </p:txBody>
@@ -5830,8 +6826,8 @@
         </p:nvSpPr>
         <p:spPr>
           <a:xfrm>
-            <a:off x="548640" y="228600"/>
-            <a:ext cx="11064240" cy="914400"/>
+            <a:off x="548640" y="201168"/>
+            <a:ext cx="11064240" cy="292608"/>
           </a:xfrm>
           <a:prstGeom prst="rect">
             <a:avLst/>
@@ -5845,33 +6841,67 @@
           <a:lstStyle/>
           <a:p>
             <a:r>
-              <a:rPr sz="2800" b="1">
-                <a:solidFill>
-                  <a:srgbClr val="1F3864"/>
-                </a:solidFill>
-                <a:latin typeface="Calibri"/>
-              </a:rPr>
-              <a:t>Methodology</a:t>
-            </a:r>
-          </a:p>
-        </p:txBody>
-      </p:sp>
-      <p:sp>
-        <p:nvSpPr>
-          <p:cNvPr id="3" name="Rectangle 2"/>
+              <a:rPr sz="1200" b="1">
+                <a:solidFill>
+                  <a:srgbClr val="C98A1F"/>
+                </a:solidFill>
+                <a:latin typeface="Calibri"/>
+              </a:rPr>
+              <a:t>04 · METHOD</a:t>
+            </a:r>
+          </a:p>
+        </p:txBody>
+      </p:sp>
+      <p:sp>
+        <p:nvSpPr>
+          <p:cNvPr id="3" name="TextBox 2"/>
+          <p:cNvSpPr txBox="1"/>
+          <p:nvPr/>
+        </p:nvSpPr>
+        <p:spPr>
+          <a:xfrm>
+            <a:off x="548640" y="475488"/>
+            <a:ext cx="11064240" cy="685800"/>
+          </a:xfrm>
+          <a:prstGeom prst="rect">
+            <a:avLst/>
+          </a:prstGeom>
+          <a:noFill/>
+        </p:spPr>
+        <p:txBody>
+          <a:bodyPr wrap="none">
+            <a:spAutoFit/>
+          </a:bodyPr>
+          <a:lstStyle/>
+          <a:p>
+            <a:r>
+              <a:rPr sz="2700" b="1">
+                <a:solidFill>
+                  <a:srgbClr val="1B3A5C"/>
+                </a:solidFill>
+                <a:latin typeface="Calibri"/>
+              </a:rPr>
+              <a:t>Build the artefact, then measure it</a:t>
+            </a:r>
+          </a:p>
+        </p:txBody>
+      </p:sp>
+      <p:sp>
+        <p:nvSpPr>
+          <p:cNvPr id="4" name="Rectangle 3"/>
           <p:cNvSpPr/>
           <p:nvPr/>
         </p:nvSpPr>
         <p:spPr>
           <a:xfrm>
-            <a:off x="548640" y="1051560"/>
-            <a:ext cx="11064240" cy="25400"/>
+            <a:off x="548640" y="1207008"/>
+            <a:ext cx="1463040" cy="38100"/>
           </a:xfrm>
           <a:prstGeom prst="rect">
             <a:avLst/>
           </a:prstGeom>
           <a:solidFill>
-            <a:srgbClr val="1F3864"/>
+            <a:srgbClr val="C98A1F"/>
           </a:solidFill>
           <a:ln>
             <a:noFill/>
@@ -5901,14 +6931,83 @@
       </p:sp>
       <p:sp>
         <p:nvSpPr>
-          <p:cNvPr id="4" name="TextBox 3"/>
+          <p:cNvPr id="5" name="TextBox 4"/>
           <p:cNvSpPr txBox="1"/>
           <p:nvPr/>
         </p:nvSpPr>
         <p:spPr>
           <a:xfrm>
-            <a:off x="548640" y="1371600"/>
-            <a:ext cx="11064240" cy="4754880"/>
+            <a:off x="548640" y="6419088"/>
+            <a:ext cx="11091672" cy="320040"/>
+          </a:xfrm>
+          <a:prstGeom prst="rect">
+            <a:avLst/>
+          </a:prstGeom>
+          <a:noFill/>
+        </p:spPr>
+        <p:txBody>
+          <a:bodyPr wrap="none">
+            <a:spAutoFit/>
+          </a:bodyPr>
+          <a:lstStyle/>
+          <a:p>
+            <a:r>
+              <a:rPr sz="1000">
+                <a:solidFill>
+                  <a:srgbClr val="6B6B6B"/>
+                </a:solidFill>
+                <a:latin typeface="Calibri"/>
+              </a:rPr>
+              <a:t>Failures — Final Year Project Defence</a:t>
+            </a:r>
+          </a:p>
+        </p:txBody>
+      </p:sp>
+      <p:sp>
+        <p:nvSpPr>
+          <p:cNvPr id="6" name="TextBox 5"/>
+          <p:cNvSpPr txBox="1"/>
+          <p:nvPr/>
+        </p:nvSpPr>
+        <p:spPr>
+          <a:xfrm>
+            <a:off x="10424160" y="6419088"/>
+            <a:ext cx="1216152" cy="320040"/>
+          </a:xfrm>
+          <a:prstGeom prst="rect">
+            <a:avLst/>
+          </a:prstGeom>
+          <a:noFill/>
+        </p:spPr>
+        <p:txBody>
+          <a:bodyPr wrap="none">
+            <a:spAutoFit/>
+          </a:bodyPr>
+          <a:lstStyle/>
+          <a:p>
+            <a:pPr algn="r"/>
+            <a:r>
+              <a:rPr sz="1000">
+                <a:solidFill>
+                  <a:srgbClr val="6B6B6B"/>
+                </a:solidFill>
+                <a:latin typeface="Calibri"/>
+              </a:rPr>
+              <a:t>05 / 11</a:t>
+            </a:r>
+          </a:p>
+        </p:txBody>
+      </p:sp>
+      <p:sp>
+        <p:nvSpPr>
+          <p:cNvPr id="7" name="TextBox 6"/>
+          <p:cNvSpPr txBox="1"/>
+          <p:nvPr/>
+        </p:nvSpPr>
+        <p:spPr>
+          <a:xfrm>
+            <a:off x="548640" y="1508760"/>
+            <a:ext cx="5120640" cy="4023360"/>
           </a:xfrm>
           <a:prstGeom prst="rect">
             <a:avLst/>
@@ -5927,13 +7026,22 @@
               </a:spcAft>
             </a:pPr>
             <a:r>
-              <a:rPr sz="1800">
-                <a:solidFill>
-                  <a:srgbClr val="333333"/>
-                </a:solidFill>
-                <a:latin typeface="Calibri"/>
-              </a:rPr>
-              <a:t>Research design: Design Science Research — build the artefact, then measure it.</a:t>
+              <a:rPr sz="1800" b="1">
+                <a:solidFill>
+                  <a:srgbClr val="C98A1F"/>
+                </a:solidFill>
+                <a:latin typeface="Calibri"/>
+              </a:rPr>
+              <a:t>▸ </a:t>
+            </a:r>
+            <a:r>
+              <a:rPr sz="1800" b="1">
+                <a:solidFill>
+                  <a:srgbClr val="1B3A5C"/>
+                </a:solidFill>
+                <a:latin typeface="Calibri"/>
+              </a:rPr>
+              <a:t>Design Science Research: build, then evaluate — not surveys, not opinion.</a:t>
             </a:r>
           </a:p>
           <a:p>
@@ -5943,13 +7051,22 @@
               </a:spcAft>
             </a:pPr>
             <a:r>
-              <a:rPr sz="1800">
-                <a:solidFill>
-                  <a:srgbClr val="333333"/>
-                </a:solidFill>
-                <a:latin typeface="Calibri"/>
-              </a:rPr>
-              <a:t>Development: Agile iterations — rules, tools, harness, each tested before the next.</a:t>
+              <a:rPr sz="1800" b="1">
+                <a:solidFill>
+                  <a:srgbClr val="C98A1F"/>
+                </a:solidFill>
+                <a:latin typeface="Calibri"/>
+              </a:rPr>
+              <a:t>▸ </a:t>
+            </a:r>
+            <a:r>
+              <a:rPr sz="1800" b="1">
+                <a:solidFill>
+                  <a:srgbClr val="1B3A5C"/>
+                </a:solidFill>
+                <a:latin typeface="Calibri"/>
+              </a:rPr>
+              <a:t>Agile: rules, tools, and harness co-evolved through iterations.</a:t>
             </a:r>
           </a:p>
           <a:p>
@@ -5959,13 +7076,22 @@
               </a:spcAft>
             </a:pPr>
             <a:r>
-              <a:rPr sz="1800">
-                <a:solidFill>
-                  <a:srgbClr val="333333"/>
-                </a:solidFill>
-                <a:latin typeface="Calibri"/>
-              </a:rPr>
-              <a:t>Data: 17 matched agent pairs + 6 proxy pairs + 6 adversarial cases.</a:t>
+              <a:rPr sz="1800" b="1">
+                <a:solidFill>
+                  <a:srgbClr val="C98A1F"/>
+                </a:solidFill>
+                <a:latin typeface="Calibri"/>
+              </a:rPr>
+              <a:t>▸ </a:t>
+            </a:r>
+            <a:r>
+              <a:rPr sz="1800" b="1">
+                <a:solidFill>
+                  <a:srgbClr val="1B3A5C"/>
+                </a:solidFill>
+                <a:latin typeface="Calibri"/>
+              </a:rPr>
+              <a:t>Data: 17 matched pairs + 6 proxy + 6 adversarial cases.</a:t>
             </a:r>
           </a:p>
           <a:p>
@@ -5975,47 +7101,286 @@
               </a:spcAft>
             </a:pPr>
             <a:r>
-              <a:rPr sz="1800">
-                <a:solidFill>
-                  <a:srgbClr val="333333"/>
-                </a:solidFill>
-                <a:latin typeface="Calibri"/>
-              </a:rPr>
-              <a:t>Instrument: one deterministic harness, ten criteria, frozen prompts and manifests.</a:t>
-            </a:r>
-          </a:p>
-        </p:txBody>
-      </p:sp>
-      <p:sp>
-        <p:nvSpPr>
-          <p:cNvPr id="5" name="TextBox 4"/>
-          <p:cNvSpPr txBox="1"/>
+              <a:rPr sz="1800" b="1">
+                <a:solidFill>
+                  <a:srgbClr val="C98A1F"/>
+                </a:solidFill>
+                <a:latin typeface="Calibri"/>
+              </a:rPr>
+              <a:t>▸ </a:t>
+            </a:r>
+            <a:r>
+              <a:rPr sz="1800" b="1">
+                <a:solidFill>
+                  <a:srgbClr val="1B3A5C"/>
+                </a:solidFill>
+                <a:latin typeface="Calibri"/>
+              </a:rPr>
+              <a:t>Instrument: one harness, ten criteria, frozen prompts and manifests.</a:t>
+            </a:r>
+          </a:p>
+        </p:txBody>
+      </p:sp>
+      <p:sp>
+        <p:nvSpPr>
+          <p:cNvPr id="8" name="Rounded Rectangle 7"/>
+          <p:cNvSpPr/>
           <p:nvPr/>
         </p:nvSpPr>
         <p:spPr>
           <a:xfrm>
-            <a:off x="548640" y="6446520"/>
-            <a:ext cx="11064240" cy="320040"/>
-          </a:xfrm>
-          <a:prstGeom prst="rect">
-            <a:avLst/>
-          </a:prstGeom>
-          <a:noFill/>
-        </p:spPr>
-        <p:txBody>
-          <a:bodyPr wrap="none">
-            <a:spAutoFit/>
-          </a:bodyPr>
-          <a:lstStyle/>
-          <a:p>
-            <a:r>
-              <a:rPr sz="1100">
-                <a:solidFill>
-                  <a:srgbClr val="595659"/>
-                </a:solidFill>
-                <a:latin typeface="Calibri"/>
-              </a:rPr>
-              <a:t>Failures — Final Year Project Defence</a:t>
+            <a:off x="6400800" y="1554480"/>
+            <a:ext cx="2514600" cy="1737360"/>
+          </a:xfrm>
+          <a:prstGeom prst="roundRect">
+            <a:avLst>
+              <a:gd name="adj" fmla="val 12000"/>
+            </a:avLst>
+          </a:prstGeom>
+          <a:solidFill>
+            <a:srgbClr val="1B3A5C"/>
+          </a:solidFill>
+          <a:ln>
+            <a:noFill/>
+          </a:ln>
+        </p:spPr>
+        <p:style>
+          <a:lnRef idx="1">
+            <a:schemeClr val="accent1"/>
+          </a:lnRef>
+          <a:fillRef idx="3">
+            <a:schemeClr val="accent1"/>
+          </a:fillRef>
+          <a:effectRef idx="2">
+            <a:schemeClr val="accent1"/>
+          </a:effectRef>
+          <a:fontRef idx="minor">
+            <a:schemeClr val="lt1"/>
+          </a:fontRef>
+        </p:style>
+        <p:txBody>
+          <a:bodyPr rtlCol="0" anchor="ctr" wrap="square"/>
+          <a:lstStyle/>
+          <a:p>
+            <a:pPr algn="ctr"/>
+            <a:r>
+              <a:rPr sz="3000" b="1">
+                <a:solidFill>
+                  <a:srgbClr val="FFFFFF"/>
+                </a:solidFill>
+                <a:latin typeface="Calibri"/>
+              </a:rPr>
+              <a:t>17</a:t>
+            </a:r>
+          </a:p>
+          <a:p>
+            <a:pPr algn="ctr"/>
+            <a:r>
+              <a:rPr sz="1200">
+                <a:solidFill>
+                  <a:srgbClr val="C98A1F"/>
+                </a:solidFill>
+                <a:latin typeface="Calibri"/>
+              </a:rPr>
+              <a:t>matched pairs</a:t>
+            </a:r>
+          </a:p>
+        </p:txBody>
+      </p:sp>
+      <p:sp>
+        <p:nvSpPr>
+          <p:cNvPr id="9" name="Rounded Rectangle 8"/>
+          <p:cNvSpPr/>
+          <p:nvPr/>
+        </p:nvSpPr>
+        <p:spPr>
+          <a:xfrm>
+            <a:off x="9144000" y="1554480"/>
+            <a:ext cx="2514600" cy="1737360"/>
+          </a:xfrm>
+          <a:prstGeom prst="roundRect">
+            <a:avLst>
+              <a:gd name="adj" fmla="val 12000"/>
+            </a:avLst>
+          </a:prstGeom>
+          <a:solidFill>
+            <a:srgbClr val="1B3A5C"/>
+          </a:solidFill>
+          <a:ln>
+            <a:noFill/>
+          </a:ln>
+        </p:spPr>
+        <p:style>
+          <a:lnRef idx="1">
+            <a:schemeClr val="accent1"/>
+          </a:lnRef>
+          <a:fillRef idx="3">
+            <a:schemeClr val="accent1"/>
+          </a:fillRef>
+          <a:effectRef idx="2">
+            <a:schemeClr val="accent1"/>
+          </a:effectRef>
+          <a:fontRef idx="minor">
+            <a:schemeClr val="lt1"/>
+          </a:fontRef>
+        </p:style>
+        <p:txBody>
+          <a:bodyPr rtlCol="0" anchor="ctr" wrap="square"/>
+          <a:lstStyle/>
+          <a:p>
+            <a:pPr algn="ctr"/>
+            <a:r>
+              <a:rPr sz="3000" b="1">
+                <a:solidFill>
+                  <a:srgbClr val="FFFFFF"/>
+                </a:solidFill>
+                <a:latin typeface="Calibri"/>
+              </a:rPr>
+              <a:t>10</a:t>
+            </a:r>
+          </a:p>
+          <a:p>
+            <a:pPr algn="ctr"/>
+            <a:r>
+              <a:rPr sz="1200">
+                <a:solidFill>
+                  <a:srgbClr val="C98A1F"/>
+                </a:solidFill>
+                <a:latin typeface="Calibri"/>
+              </a:rPr>
+              <a:t>scored criteria</a:t>
+            </a:r>
+          </a:p>
+        </p:txBody>
+      </p:sp>
+      <p:sp>
+        <p:nvSpPr>
+          <p:cNvPr id="10" name="Rounded Rectangle 9"/>
+          <p:cNvSpPr/>
+          <p:nvPr/>
+        </p:nvSpPr>
+        <p:spPr>
+          <a:xfrm>
+            <a:off x="6400800" y="3520440"/>
+            <a:ext cx="2514600" cy="1737360"/>
+          </a:xfrm>
+          <a:prstGeom prst="roundRect">
+            <a:avLst>
+              <a:gd name="adj" fmla="val 12000"/>
+            </a:avLst>
+          </a:prstGeom>
+          <a:solidFill>
+            <a:srgbClr val="1B3A5C"/>
+          </a:solidFill>
+          <a:ln>
+            <a:noFill/>
+          </a:ln>
+        </p:spPr>
+        <p:style>
+          <a:lnRef idx="1">
+            <a:schemeClr val="accent1"/>
+          </a:lnRef>
+          <a:fillRef idx="3">
+            <a:schemeClr val="accent1"/>
+          </a:fillRef>
+          <a:effectRef idx="2">
+            <a:schemeClr val="accent1"/>
+          </a:effectRef>
+          <a:fontRef idx="minor">
+            <a:schemeClr val="lt1"/>
+          </a:fontRef>
+        </p:style>
+        <p:txBody>
+          <a:bodyPr rtlCol="0" anchor="ctr" wrap="square"/>
+          <a:lstStyle/>
+          <a:p>
+            <a:pPr algn="ctr"/>
+            <a:r>
+              <a:rPr sz="3000" b="1">
+                <a:solidFill>
+                  <a:srgbClr val="FFFFFF"/>
+                </a:solidFill>
+                <a:latin typeface="Calibri"/>
+              </a:rPr>
+              <a:t>6+6</a:t>
+            </a:r>
+          </a:p>
+          <a:p>
+            <a:pPr algn="ctr"/>
+            <a:r>
+              <a:rPr sz="1200">
+                <a:solidFill>
+                  <a:srgbClr val="C98A1F"/>
+                </a:solidFill>
+                <a:latin typeface="Calibri"/>
+              </a:rPr>
+              <a:t>scenarios + adversarial</a:t>
+            </a:r>
+          </a:p>
+        </p:txBody>
+      </p:sp>
+      <p:sp>
+        <p:nvSpPr>
+          <p:cNvPr id="11" name="Rounded Rectangle 10"/>
+          <p:cNvSpPr/>
+          <p:nvPr/>
+        </p:nvSpPr>
+        <p:spPr>
+          <a:xfrm>
+            <a:off x="9144000" y="3520440"/>
+            <a:ext cx="2514600" cy="1737360"/>
+          </a:xfrm>
+          <a:prstGeom prst="roundRect">
+            <a:avLst>
+              <a:gd name="adj" fmla="val 12000"/>
+            </a:avLst>
+          </a:prstGeom>
+          <a:solidFill>
+            <a:srgbClr val="1B3A5C"/>
+          </a:solidFill>
+          <a:ln>
+            <a:noFill/>
+          </a:ln>
+        </p:spPr>
+        <p:style>
+          <a:lnRef idx="1">
+            <a:schemeClr val="accent1"/>
+          </a:lnRef>
+          <a:fillRef idx="3">
+            <a:schemeClr val="accent1"/>
+          </a:fillRef>
+          <a:effectRef idx="2">
+            <a:schemeClr val="accent1"/>
+          </a:effectRef>
+          <a:fontRef idx="minor">
+            <a:schemeClr val="lt1"/>
+          </a:fontRef>
+        </p:style>
+        <p:txBody>
+          <a:bodyPr rtlCol="0" anchor="ctr" wrap="square"/>
+          <a:lstStyle/>
+          <a:p>
+            <a:pPr algn="ctr"/>
+            <a:r>
+              <a:rPr sz="3000" b="1">
+                <a:solidFill>
+                  <a:srgbClr val="FFFFFF"/>
+                </a:solidFill>
+                <a:latin typeface="Calibri"/>
+              </a:rPr>
+              <a:t>3</a:t>
+            </a:r>
+          </a:p>
+          <a:p>
+            <a:pPr algn="ctr"/>
+            <a:r>
+              <a:rPr sz="1200">
+                <a:solidFill>
+                  <a:srgbClr val="C98A1F"/>
+                </a:solidFill>
+                <a:latin typeface="Calibri"/>
+              </a:rPr>
+              <a:t>commercial agents</a:t>
             </a:r>
           </a:p>
         </p:txBody>
@@ -6046,8 +7411,8 @@
         </p:nvSpPr>
         <p:spPr>
           <a:xfrm>
-            <a:off x="548640" y="228600"/>
-            <a:ext cx="11064240" cy="914400"/>
+            <a:off x="548640" y="201168"/>
+            <a:ext cx="11064240" cy="292608"/>
           </a:xfrm>
           <a:prstGeom prst="rect">
             <a:avLst/>
@@ -6061,33 +7426,67 @@
           <a:lstStyle/>
           <a:p>
             <a:r>
-              <a:rPr sz="2800" b="1">
-                <a:solidFill>
-                  <a:srgbClr val="1F3864"/>
-                </a:solidFill>
-                <a:latin typeface="Calibri"/>
-              </a:rPr>
-              <a:t>System architecture</a:t>
-            </a:r>
-          </a:p>
-        </p:txBody>
-      </p:sp>
-      <p:sp>
-        <p:nvSpPr>
-          <p:cNvPr id="3" name="Rectangle 2"/>
+              <a:rPr sz="1200" b="1">
+                <a:solidFill>
+                  <a:srgbClr val="C98A1F"/>
+                </a:solidFill>
+                <a:latin typeface="Calibri"/>
+              </a:rPr>
+              <a:t>05 · SYSTEM</a:t>
+            </a:r>
+          </a:p>
+        </p:txBody>
+      </p:sp>
+      <p:sp>
+        <p:nvSpPr>
+          <p:cNvPr id="3" name="TextBox 2"/>
+          <p:cNvSpPr txBox="1"/>
+          <p:nvPr/>
+        </p:nvSpPr>
+        <p:spPr>
+          <a:xfrm>
+            <a:off x="548640" y="475488"/>
+            <a:ext cx="11064240" cy="685800"/>
+          </a:xfrm>
+          <a:prstGeom prst="rect">
+            <a:avLst/>
+          </a:prstGeom>
+          <a:noFill/>
+        </p:spPr>
+        <p:txBody>
+          <a:bodyPr wrap="none">
+            <a:spAutoFit/>
+          </a:bodyPr>
+          <a:lstStyle/>
+          <a:p>
+            <a:r>
+              <a:rPr sz="2700" b="1">
+                <a:solidFill>
+                  <a:srgbClr val="1B3A5C"/>
+                </a:solidFill>
+                <a:latin typeface="Calibri"/>
+              </a:rPr>
+              <a:t>One server, any agent, zero token cost</a:t>
+            </a:r>
+          </a:p>
+        </p:txBody>
+      </p:sp>
+      <p:sp>
+        <p:nvSpPr>
+          <p:cNvPr id="4" name="Rectangle 3"/>
           <p:cNvSpPr/>
           <p:nvPr/>
         </p:nvSpPr>
         <p:spPr>
           <a:xfrm>
-            <a:off x="548640" y="1051560"/>
-            <a:ext cx="11064240" cy="25400"/>
+            <a:off x="548640" y="1207008"/>
+            <a:ext cx="1463040" cy="38100"/>
           </a:xfrm>
           <a:prstGeom prst="rect">
             <a:avLst/>
           </a:prstGeom>
           <a:solidFill>
-            <a:srgbClr val="1F3864"/>
+            <a:srgbClr val="C98A1F"/>
           </a:solidFill>
           <a:ln>
             <a:noFill/>
@@ -6117,14 +7516,83 @@
       </p:sp>
       <p:sp>
         <p:nvSpPr>
-          <p:cNvPr id="4" name="TextBox 3"/>
+          <p:cNvPr id="5" name="TextBox 4"/>
           <p:cNvSpPr txBox="1"/>
           <p:nvPr/>
         </p:nvSpPr>
         <p:spPr>
           <a:xfrm>
-            <a:off x="548640" y="1371600"/>
-            <a:ext cx="5303520" cy="4754880"/>
+            <a:off x="548640" y="6419088"/>
+            <a:ext cx="11091672" cy="320040"/>
+          </a:xfrm>
+          <a:prstGeom prst="rect">
+            <a:avLst/>
+          </a:prstGeom>
+          <a:noFill/>
+        </p:spPr>
+        <p:txBody>
+          <a:bodyPr wrap="none">
+            <a:spAutoFit/>
+          </a:bodyPr>
+          <a:lstStyle/>
+          <a:p>
+            <a:r>
+              <a:rPr sz="1000">
+                <a:solidFill>
+                  <a:srgbClr val="6B6B6B"/>
+                </a:solidFill>
+                <a:latin typeface="Calibri"/>
+              </a:rPr>
+              <a:t>Failures — Final Year Project Defence</a:t>
+            </a:r>
+          </a:p>
+        </p:txBody>
+      </p:sp>
+      <p:sp>
+        <p:nvSpPr>
+          <p:cNvPr id="6" name="TextBox 5"/>
+          <p:cNvSpPr txBox="1"/>
+          <p:nvPr/>
+        </p:nvSpPr>
+        <p:spPr>
+          <a:xfrm>
+            <a:off x="10424160" y="6419088"/>
+            <a:ext cx="1216152" cy="320040"/>
+          </a:xfrm>
+          <a:prstGeom prst="rect">
+            <a:avLst/>
+          </a:prstGeom>
+          <a:noFill/>
+        </p:spPr>
+        <p:txBody>
+          <a:bodyPr wrap="none">
+            <a:spAutoFit/>
+          </a:bodyPr>
+          <a:lstStyle/>
+          <a:p>
+            <a:pPr algn="r"/>
+            <a:r>
+              <a:rPr sz="1000">
+                <a:solidFill>
+                  <a:srgbClr val="6B6B6B"/>
+                </a:solidFill>
+                <a:latin typeface="Calibri"/>
+              </a:rPr>
+              <a:t>06 / 11</a:t>
+            </a:r>
+          </a:p>
+        </p:txBody>
+      </p:sp>
+      <p:sp>
+        <p:nvSpPr>
+          <p:cNvPr id="7" name="TextBox 6"/>
+          <p:cNvSpPr txBox="1"/>
+          <p:nvPr/>
+        </p:nvSpPr>
+        <p:spPr>
+          <a:xfrm>
+            <a:off x="548640" y="1508760"/>
+            <a:ext cx="5120640" cy="4023360"/>
           </a:xfrm>
           <a:prstGeom prst="rect">
             <a:avLst/>
@@ -6143,9 +7611,18 @@
               </a:spcAft>
             </a:pPr>
             <a:r>
-              <a:rPr sz="1700">
-                <a:solidFill>
-                  <a:srgbClr val="333333"/>
+              <a:rPr sz="1800" b="1">
+                <a:solidFill>
+                  <a:srgbClr val="C98A1F"/>
+                </a:solidFill>
+                <a:latin typeface="Calibri"/>
+              </a:rPr>
+              <a:t>▸ </a:t>
+            </a:r>
+            <a:r>
+              <a:rPr sz="1800" b="1">
+                <a:solidFill>
+                  <a:srgbClr val="1B3A5C"/>
                 </a:solidFill>
                 <a:latin typeface="Calibri"/>
               </a:rPr>
@@ -6159,13 +7636,22 @@
               </a:spcAft>
             </a:pPr>
             <a:r>
-              <a:rPr sz="1700">
-                <a:solidFill>
-                  <a:srgbClr val="333333"/>
-                </a:solidFill>
-                <a:latin typeface="Calibri"/>
-              </a:rPr>
-              <a:t>Deterministic engine: review, score, never hallucinates.</a:t>
+              <a:rPr sz="1800" b="1">
+                <a:solidFill>
+                  <a:srgbClr val="C98A1F"/>
+                </a:solidFill>
+                <a:latin typeface="Calibri"/>
+              </a:rPr>
+              <a:t>▸ </a:t>
+            </a:r>
+            <a:r>
+              <a:rPr sz="1800" b="1">
+                <a:solidFill>
+                  <a:srgbClr val="1B3A5C"/>
+                </a:solidFill>
+                <a:latin typeface="Calibri"/>
+              </a:rPr>
+              <a:t>Deterministic engine: review and score — never hallucinates.</a:t>
             </a:r>
           </a:p>
           <a:p>
@@ -6175,20 +7661,29 @@
               </a:spcAft>
             </a:pPr>
             <a:r>
-              <a:rPr sz="1700">
-                <a:solidFill>
-                  <a:srgbClr val="333333"/>
-                </a:solidFill>
-                <a:latin typeface="Calibri"/>
-              </a:rPr>
-              <a:t>13 MCP tools: any compliant agent can call them at zero token cost.</a:t>
+              <a:rPr sz="1800" b="1">
+                <a:solidFill>
+                  <a:srgbClr val="C98A1F"/>
+                </a:solidFill>
+                <a:latin typeface="Calibri"/>
+              </a:rPr>
+              <a:t>▸ </a:t>
+            </a:r>
+            <a:r>
+              <a:rPr sz="1800" b="1">
+                <a:solidFill>
+                  <a:srgbClr val="1B3A5C"/>
+                </a:solidFill>
+                <a:latin typeface="Calibri"/>
+              </a:rPr>
+              <a:t>13 MCP tools: any compliant agent calls them; findings carry evidence.</a:t>
             </a:r>
           </a:p>
         </p:txBody>
       </p:sp>
       <p:pic>
         <p:nvPicPr>
-          <p:cNvPr id="5" name="Picture 4" descr="fig31_architecture.png"/>
+          <p:cNvPr id="8" name="Picture 7" descr="fig31_architecture.png"/>
           <p:cNvPicPr>
             <a:picLocks noChangeAspect="1"/>
           </p:cNvPicPr>
@@ -6202,48 +7697,14 @@
         </p:blipFill>
         <p:spPr>
           <a:xfrm>
-            <a:off x="6126480" y="1371600"/>
-            <a:ext cx="5486400" cy="4206240"/>
+            <a:off x="6126480" y="1463040"/>
+            <a:ext cx="5486400" cy="4114800"/>
           </a:xfrm>
           <a:prstGeom prst="rect">
             <a:avLst/>
           </a:prstGeom>
         </p:spPr>
       </p:pic>
-      <p:sp>
-        <p:nvSpPr>
-          <p:cNvPr id="6" name="TextBox 5"/>
-          <p:cNvSpPr txBox="1"/>
-          <p:nvPr/>
-        </p:nvSpPr>
-        <p:spPr>
-          <a:xfrm>
-            <a:off x="548640" y="6446520"/>
-            <a:ext cx="11064240" cy="320040"/>
-          </a:xfrm>
-          <a:prstGeom prst="rect">
-            <a:avLst/>
-          </a:prstGeom>
-          <a:noFill/>
-        </p:spPr>
-        <p:txBody>
-          <a:bodyPr wrap="none">
-            <a:spAutoFit/>
-          </a:bodyPr>
-          <a:lstStyle/>
-          <a:p>
-            <a:r>
-              <a:rPr sz="1100">
-                <a:solidFill>
-                  <a:srgbClr val="595659"/>
-                </a:solidFill>
-                <a:latin typeface="Calibri"/>
-              </a:rPr>
-              <a:t>Failures — Final Year Project Defence</a:t>
-            </a:r>
-          </a:p>
-        </p:txBody>
-      </p:sp>
     </p:spTree>
   </p:cSld>
   <p:clrMapOvr>
@@ -6270,8 +7731,8 @@
         </p:nvSpPr>
         <p:spPr>
           <a:xfrm>
-            <a:off x="548640" y="228600"/>
-            <a:ext cx="11064240" cy="914400"/>
+            <a:off x="548640" y="201168"/>
+            <a:ext cx="11064240" cy="292608"/>
           </a:xfrm>
           <a:prstGeom prst="rect">
             <a:avLst/>
@@ -6285,33 +7746,67 @@
           <a:lstStyle/>
           <a:p>
             <a:r>
-              <a:rPr sz="2800" b="1">
-                <a:solidFill>
-                  <a:srgbClr val="1F3864"/>
-                </a:solidFill>
-                <a:latin typeface="Calibri"/>
-              </a:rPr>
-              <a:t>How evaluation works</a:t>
-            </a:r>
-          </a:p>
-        </p:txBody>
-      </p:sp>
-      <p:sp>
-        <p:nvSpPr>
-          <p:cNvPr id="3" name="Rectangle 2"/>
+              <a:rPr sz="1200" b="1">
+                <a:solidFill>
+                  <a:srgbClr val="C98A1F"/>
+                </a:solidFill>
+                <a:latin typeface="Calibri"/>
+              </a:rPr>
+              <a:t>06 · EVALUATION</a:t>
+            </a:r>
+          </a:p>
+        </p:txBody>
+      </p:sp>
+      <p:sp>
+        <p:nvSpPr>
+          <p:cNvPr id="3" name="TextBox 2"/>
+          <p:cNvSpPr txBox="1"/>
+          <p:nvPr/>
+        </p:nvSpPr>
+        <p:spPr>
+          <a:xfrm>
+            <a:off x="548640" y="475488"/>
+            <a:ext cx="11064240" cy="685800"/>
+          </a:xfrm>
+          <a:prstGeom prst="rect">
+            <a:avLst/>
+          </a:prstGeom>
+          <a:noFill/>
+        </p:spPr>
+        <p:txBody>
+          <a:bodyPr wrap="none">
+            <a:spAutoFit/>
+          </a:bodyPr>
+          <a:lstStyle/>
+          <a:p>
+            <a:r>
+              <a:rPr sz="2700" b="1">
+                <a:solidFill>
+                  <a:srgbClr val="1B3A5C"/>
+                </a:solidFill>
+                <a:latin typeface="Calibri"/>
+              </a:rPr>
+              <a:t>One variable changed, everything else frozen</a:t>
+            </a:r>
+          </a:p>
+        </p:txBody>
+      </p:sp>
+      <p:sp>
+        <p:nvSpPr>
+          <p:cNvPr id="4" name="Rectangle 3"/>
           <p:cNvSpPr/>
           <p:nvPr/>
         </p:nvSpPr>
         <p:spPr>
           <a:xfrm>
-            <a:off x="548640" y="1051560"/>
-            <a:ext cx="11064240" cy="25400"/>
+            <a:off x="548640" y="1207008"/>
+            <a:ext cx="1463040" cy="38100"/>
           </a:xfrm>
           <a:prstGeom prst="rect">
             <a:avLst/>
           </a:prstGeom>
           <a:solidFill>
-            <a:srgbClr val="1F3864"/>
+            <a:srgbClr val="C98A1F"/>
           </a:solidFill>
           <a:ln>
             <a:noFill/>
@@ -6341,14 +7836,83 @@
       </p:sp>
       <p:sp>
         <p:nvSpPr>
-          <p:cNvPr id="4" name="TextBox 3"/>
+          <p:cNvPr id="5" name="TextBox 4"/>
           <p:cNvSpPr txBox="1"/>
           <p:nvPr/>
         </p:nvSpPr>
         <p:spPr>
           <a:xfrm>
-            <a:off x="548640" y="1371600"/>
-            <a:ext cx="5303520" cy="4754880"/>
+            <a:off x="548640" y="6419088"/>
+            <a:ext cx="11091672" cy="320040"/>
+          </a:xfrm>
+          <a:prstGeom prst="rect">
+            <a:avLst/>
+          </a:prstGeom>
+          <a:noFill/>
+        </p:spPr>
+        <p:txBody>
+          <a:bodyPr wrap="none">
+            <a:spAutoFit/>
+          </a:bodyPr>
+          <a:lstStyle/>
+          <a:p>
+            <a:r>
+              <a:rPr sz="1000">
+                <a:solidFill>
+                  <a:srgbClr val="6B6B6B"/>
+                </a:solidFill>
+                <a:latin typeface="Calibri"/>
+              </a:rPr>
+              <a:t>Failures — Final Year Project Defence</a:t>
+            </a:r>
+          </a:p>
+        </p:txBody>
+      </p:sp>
+      <p:sp>
+        <p:nvSpPr>
+          <p:cNvPr id="6" name="TextBox 5"/>
+          <p:cNvSpPr txBox="1"/>
+          <p:nvPr/>
+        </p:nvSpPr>
+        <p:spPr>
+          <a:xfrm>
+            <a:off x="10424160" y="6419088"/>
+            <a:ext cx="1216152" cy="320040"/>
+          </a:xfrm>
+          <a:prstGeom prst="rect">
+            <a:avLst/>
+          </a:prstGeom>
+          <a:noFill/>
+        </p:spPr>
+        <p:txBody>
+          <a:bodyPr wrap="none">
+            <a:spAutoFit/>
+          </a:bodyPr>
+          <a:lstStyle/>
+          <a:p>
+            <a:pPr algn="r"/>
+            <a:r>
+              <a:rPr sz="1000">
+                <a:solidFill>
+                  <a:srgbClr val="6B6B6B"/>
+                </a:solidFill>
+                <a:latin typeface="Calibri"/>
+              </a:rPr>
+              <a:t>07 / 11</a:t>
+            </a:r>
+          </a:p>
+        </p:txBody>
+      </p:sp>
+      <p:sp>
+        <p:nvSpPr>
+          <p:cNvPr id="7" name="TextBox 6"/>
+          <p:cNvSpPr txBox="1"/>
+          <p:nvPr/>
+        </p:nvSpPr>
+        <p:spPr>
+          <a:xfrm>
+            <a:off x="548640" y="1508760"/>
+            <a:ext cx="5120640" cy="4023360"/>
           </a:xfrm>
           <a:prstGeom prst="rect">
             <a:avLst/>
@@ -6367,9 +7931,18 @@
               </a:spcAft>
             </a:pPr>
             <a:r>
-              <a:rPr sz="1700">
-                <a:solidFill>
-                  <a:srgbClr val="333333"/>
+              <a:rPr sz="1800" b="1">
+                <a:solidFill>
+                  <a:srgbClr val="C98A1F"/>
+                </a:solidFill>
+                <a:latin typeface="Calibri"/>
+              </a:rPr>
+              <a:t>▸ </a:t>
+            </a:r>
+            <a:r>
+              <a:rPr sz="1800" b="1">
+                <a:solidFill>
+                  <a:srgbClr val="1B3A5C"/>
                 </a:solidFill>
                 <a:latin typeface="Calibri"/>
               </a:rPr>
@@ -6383,13 +7956,22 @@
               </a:spcAft>
             </a:pPr>
             <a:r>
-              <a:rPr sz="1700">
-                <a:solidFill>
-                  <a:srgbClr val="333333"/>
-                </a:solidFill>
-                <a:latin typeface="Calibri"/>
-              </a:rPr>
-              <a:t>Three agents: Claude, Cursor, Codex — 17 matched pairs.</a:t>
+              <a:rPr sz="1800" b="1">
+                <a:solidFill>
+                  <a:srgbClr val="C98A1F"/>
+                </a:solidFill>
+                <a:latin typeface="Calibri"/>
+              </a:rPr>
+              <a:t>▸ </a:t>
+            </a:r>
+            <a:r>
+              <a:rPr sz="1800" b="1">
+                <a:solidFill>
+                  <a:srgbClr val="1B3A5C"/>
+                </a:solidFill>
+                <a:latin typeface="Calibri"/>
+              </a:rPr>
+              <a:t>Claude, Cursor, Codex — 17 matched pairs, no per-agent tuning.</a:t>
             </a:r>
           </a:p>
           <a:p>
@@ -6399,20 +7981,29 @@
               </a:spcAft>
             </a:pPr>
             <a:r>
-              <a:rPr sz="1700">
-                <a:solidFill>
-                  <a:srgbClr val="333333"/>
-                </a:solidFill>
-                <a:latin typeface="Calibri"/>
-              </a:rPr>
-              <a:t>One harness scores all: findings, invariants, proportionality.</a:t>
+              <a:rPr sz="1800" b="1">
+                <a:solidFill>
+                  <a:srgbClr val="C98A1F"/>
+                </a:solidFill>
+                <a:latin typeface="Calibri"/>
+              </a:rPr>
+              <a:t>▸ </a:t>
+            </a:r>
+            <a:r>
+              <a:rPr sz="1800" b="1">
+                <a:solidFill>
+                  <a:srgbClr val="1B3A5C"/>
+                </a:solidFill>
+                <a:latin typeface="Calibri"/>
+              </a:rPr>
+              <a:t>Frozen prompt hashes, manifests, commits — fully reproducible.</a:t>
             </a:r>
           </a:p>
         </p:txBody>
       </p:sp>
       <p:pic>
         <p:nvPicPr>
-          <p:cNvPr id="5" name="Picture 4" descr="fig34_eval_flow.png"/>
+          <p:cNvPr id="8" name="Picture 7" descr="fig34_eval_flow.png"/>
           <p:cNvPicPr>
             <a:picLocks noChangeAspect="1"/>
           </p:cNvPicPr>
@@ -6426,48 +8017,14 @@
         </p:blipFill>
         <p:spPr>
           <a:xfrm>
-            <a:off x="6126480" y="1463040"/>
-            <a:ext cx="5486400" cy="3291840"/>
+            <a:off x="6126480" y="1554480"/>
+            <a:ext cx="5486400" cy="3108960"/>
           </a:xfrm>
           <a:prstGeom prst="rect">
             <a:avLst/>
           </a:prstGeom>
         </p:spPr>
       </p:pic>
-      <p:sp>
-        <p:nvSpPr>
-          <p:cNvPr id="6" name="TextBox 5"/>
-          <p:cNvSpPr txBox="1"/>
-          <p:nvPr/>
-        </p:nvSpPr>
-        <p:spPr>
-          <a:xfrm>
-            <a:off x="548640" y="6446520"/>
-            <a:ext cx="11064240" cy="320040"/>
-          </a:xfrm>
-          <a:prstGeom prst="rect">
-            <a:avLst/>
-          </a:prstGeom>
-          <a:noFill/>
-        </p:spPr>
-        <p:txBody>
-          <a:bodyPr wrap="none">
-            <a:spAutoFit/>
-          </a:bodyPr>
-          <a:lstStyle/>
-          <a:p>
-            <a:r>
-              <a:rPr sz="1100">
-                <a:solidFill>
-                  <a:srgbClr val="595659"/>
-                </a:solidFill>
-                <a:latin typeface="Calibri"/>
-              </a:rPr>
-              <a:t>Failures — Final Year Project Defence</a:t>
-            </a:r>
-          </a:p>
-        </p:txBody>
-      </p:sp>
     </p:spTree>
   </p:cSld>
   <p:clrMapOvr>
@@ -6494,8 +8051,8 @@
         </p:nvSpPr>
         <p:spPr>
           <a:xfrm>
-            <a:off x="548640" y="228600"/>
-            <a:ext cx="11064240" cy="914400"/>
+            <a:off x="548640" y="201168"/>
+            <a:ext cx="11064240" cy="292608"/>
           </a:xfrm>
           <a:prstGeom prst="rect">
             <a:avLst/>
@@ -6509,33 +8066,67 @@
           <a:lstStyle/>
           <a:p>
             <a:r>
-              <a:rPr sz="2800" b="1">
-                <a:solidFill>
-                  <a:srgbClr val="1F3864"/>
-                </a:solidFill>
-                <a:latin typeface="Calibri"/>
-              </a:rPr>
-              <a:t>Results I — proxy study</a:t>
-            </a:r>
-          </a:p>
-        </p:txBody>
-      </p:sp>
-      <p:sp>
-        <p:nvSpPr>
-          <p:cNvPr id="3" name="Rectangle 2"/>
+              <a:rPr sz="1200" b="1">
+                <a:solidFill>
+                  <a:srgbClr val="C98A1F"/>
+                </a:solidFill>
+                <a:latin typeface="Calibri"/>
+              </a:rPr>
+              <a:t>07 · RESULTS I</a:t>
+            </a:r>
+          </a:p>
+        </p:txBody>
+      </p:sp>
+      <p:sp>
+        <p:nvSpPr>
+          <p:cNvPr id="3" name="TextBox 2"/>
+          <p:cNvSpPr txBox="1"/>
+          <p:nvPr/>
+        </p:nvSpPr>
+        <p:spPr>
+          <a:xfrm>
+            <a:off x="548640" y="475488"/>
+            <a:ext cx="11064240" cy="685800"/>
+          </a:xfrm>
+          <a:prstGeom prst="rect">
+            <a:avLst/>
+          </a:prstGeom>
+          <a:noFill/>
+        </p:spPr>
+        <p:txBody>
+          <a:bodyPr wrap="none">
+            <a:spAutoFit/>
+          </a:bodyPr>
+          <a:lstStyle/>
+          <a:p>
+            <a:r>
+              <a:rPr sz="2700" b="1">
+                <a:solidFill>
+                  <a:srgbClr val="1B3A5C"/>
+                </a:solidFill>
+                <a:latin typeface="Calibri"/>
+              </a:rPr>
+              <a:t>The instrument sees improvement where it exists</a:t>
+            </a:r>
+          </a:p>
+        </p:txBody>
+      </p:sp>
+      <p:sp>
+        <p:nvSpPr>
+          <p:cNvPr id="4" name="Rectangle 3"/>
           <p:cNvSpPr/>
           <p:nvPr/>
         </p:nvSpPr>
         <p:spPr>
           <a:xfrm>
-            <a:off x="548640" y="1051560"/>
-            <a:ext cx="11064240" cy="25400"/>
+            <a:off x="548640" y="1207008"/>
+            <a:ext cx="1463040" cy="38100"/>
           </a:xfrm>
           <a:prstGeom prst="rect">
             <a:avLst/>
           </a:prstGeom>
           <a:solidFill>
-            <a:srgbClr val="1F3864"/>
+            <a:srgbClr val="C98A1F"/>
           </a:solidFill>
           <a:ln>
             <a:noFill/>
@@ -6565,14 +8156,83 @@
       </p:sp>
       <p:sp>
         <p:nvSpPr>
-          <p:cNvPr id="4" name="TextBox 3"/>
+          <p:cNvPr id="5" name="TextBox 4"/>
           <p:cNvSpPr txBox="1"/>
           <p:nvPr/>
         </p:nvSpPr>
         <p:spPr>
           <a:xfrm>
-            <a:off x="548640" y="1371600"/>
-            <a:ext cx="5303520" cy="4754880"/>
+            <a:off x="548640" y="6419088"/>
+            <a:ext cx="11091672" cy="320040"/>
+          </a:xfrm>
+          <a:prstGeom prst="rect">
+            <a:avLst/>
+          </a:prstGeom>
+          <a:noFill/>
+        </p:spPr>
+        <p:txBody>
+          <a:bodyPr wrap="none">
+            <a:spAutoFit/>
+          </a:bodyPr>
+          <a:lstStyle/>
+          <a:p>
+            <a:r>
+              <a:rPr sz="1000">
+                <a:solidFill>
+                  <a:srgbClr val="6B6B6B"/>
+                </a:solidFill>
+                <a:latin typeface="Calibri"/>
+              </a:rPr>
+              <a:t>Failures — Final Year Project Defence</a:t>
+            </a:r>
+          </a:p>
+        </p:txBody>
+      </p:sp>
+      <p:sp>
+        <p:nvSpPr>
+          <p:cNvPr id="6" name="TextBox 5"/>
+          <p:cNvSpPr txBox="1"/>
+          <p:nvPr/>
+        </p:nvSpPr>
+        <p:spPr>
+          <a:xfrm>
+            <a:off x="10424160" y="6419088"/>
+            <a:ext cx="1216152" cy="320040"/>
+          </a:xfrm>
+          <a:prstGeom prst="rect">
+            <a:avLst/>
+          </a:prstGeom>
+          <a:noFill/>
+        </p:spPr>
+        <p:txBody>
+          <a:bodyPr wrap="none">
+            <a:spAutoFit/>
+          </a:bodyPr>
+          <a:lstStyle/>
+          <a:p>
+            <a:pPr algn="r"/>
+            <a:r>
+              <a:rPr sz="1000">
+                <a:solidFill>
+                  <a:srgbClr val="6B6B6B"/>
+                </a:solidFill>
+                <a:latin typeface="Calibri"/>
+              </a:rPr>
+              <a:t>08 / 11</a:t>
+            </a:r>
+          </a:p>
+        </p:txBody>
+      </p:sp>
+      <p:sp>
+        <p:nvSpPr>
+          <p:cNvPr id="7" name="TextBox 6"/>
+          <p:cNvSpPr txBox="1"/>
+          <p:nvPr/>
+        </p:nvSpPr>
+        <p:spPr>
+          <a:xfrm>
+            <a:off x="548640" y="1508760"/>
+            <a:ext cx="5120640" cy="3291840"/>
           </a:xfrm>
           <a:prstGeom prst="rect">
             <a:avLst/>
@@ -6591,9 +8251,18 @@
               </a:spcAft>
             </a:pPr>
             <a:r>
-              <a:rPr sz="1700">
-                <a:solidFill>
-                  <a:srgbClr val="333333"/>
+              <a:rPr sz="1800" b="1">
+                <a:solidFill>
+                  <a:srgbClr val="C98A1F"/>
+                </a:solidFill>
+                <a:latin typeface="Calibri"/>
+              </a:rPr>
+              <a:t>▸ </a:t>
+            </a:r>
+            <a:r>
+              <a:rPr sz="1800" b="1">
+                <a:solidFill>
+                  <a:srgbClr val="1B3A5C"/>
                 </a:solidFill>
                 <a:latin typeface="Calibri"/>
               </a:rPr>
@@ -6607,9 +8276,18 @@
               </a:spcAft>
             </a:pPr>
             <a:r>
-              <a:rPr sz="1700">
-                <a:solidFill>
-                  <a:srgbClr val="333333"/>
+              <a:rPr sz="1800" b="1">
+                <a:solidFill>
+                  <a:srgbClr val="C98A1F"/>
+                </a:solidFill>
+                <a:latin typeface="Calibri"/>
+              </a:rPr>
+              <a:t>▸ </a:t>
+            </a:r>
+            <a:r>
+              <a:rPr sz="1800" b="1">
+                <a:solidFill>
+                  <a:srgbClr val="1B3A5C"/>
                 </a:solidFill>
                 <a:latin typeface="Calibri"/>
               </a:rPr>
@@ -6623,20 +8301,29 @@
               </a:spcAft>
             </a:pPr>
             <a:r>
-              <a:rPr sz="1700">
-                <a:solidFill>
-                  <a:srgbClr val="333333"/>
-                </a:solidFill>
-                <a:latin typeface="Calibri"/>
-              </a:rPr>
-              <a:t>Architecture quality 1.0 throughout: nothing bought with infrastructure.</a:t>
+              <a:rPr sz="1800" b="1">
+                <a:solidFill>
+                  <a:srgbClr val="C98A1F"/>
+                </a:solidFill>
+                <a:latin typeface="Calibri"/>
+              </a:rPr>
+              <a:t>▸ </a:t>
+            </a:r>
+            <a:r>
+              <a:rPr sz="1800" b="1">
+                <a:solidFill>
+                  <a:srgbClr val="1B3A5C"/>
+                </a:solidFill>
+                <a:latin typeface="Calibri"/>
+              </a:rPr>
+              <a:t>Architecture 1.0 throughout — nothing bought with infrastructure.</a:t>
             </a:r>
           </a:p>
         </p:txBody>
       </p:sp>
       <p:pic>
         <p:nvPicPr>
-          <p:cNvPr id="5" name="Picture 4" descr="fig41_proxy.png"/>
+          <p:cNvPr id="8" name="Picture 7" descr="fig41_proxy.png"/>
           <p:cNvPicPr>
             <a:picLocks noChangeAspect="1"/>
           </p:cNvPicPr>
@@ -6651,7 +8338,7 @@
         <p:spPr>
           <a:xfrm>
             <a:off x="6126480" y="1463040"/>
-            <a:ext cx="5486400" cy="4023360"/>
+            <a:ext cx="5486400" cy="3931920"/>
           </a:xfrm>
           <a:prstGeom prst="rect">
             <a:avLst/>
@@ -6660,14 +8347,57 @@
       </p:pic>
       <p:sp>
         <p:nvSpPr>
-          <p:cNvPr id="6" name="TextBox 5"/>
+          <p:cNvPr id="9" name="Rectangle 8"/>
+          <p:cNvSpPr/>
+          <p:nvPr/>
+        </p:nvSpPr>
+        <p:spPr>
+          <a:xfrm>
+            <a:off x="548640" y="5806440"/>
+            <a:ext cx="11091672" cy="502920"/>
+          </a:xfrm>
+          <a:prstGeom prst="rect">
+            <a:avLst/>
+          </a:prstGeom>
+          <a:solidFill>
+            <a:srgbClr val="FDF3E3"/>
+          </a:solidFill>
+          <a:ln>
+            <a:noFill/>
+          </a:ln>
+        </p:spPr>
+        <p:style>
+          <a:lnRef idx="1">
+            <a:schemeClr val="accent1"/>
+          </a:lnRef>
+          <a:fillRef idx="3">
+            <a:schemeClr val="accent1"/>
+          </a:fillRef>
+          <a:effectRef idx="2">
+            <a:schemeClr val="accent1"/>
+          </a:effectRef>
+          <a:fontRef idx="minor">
+            <a:schemeClr val="lt1"/>
+          </a:fontRef>
+        </p:style>
+        <p:txBody>
+          <a:bodyPr rtlCol="0" anchor="ctr"/>
+          <a:lstStyle/>
+          <a:p>
+            <a:pPr algn="ctr"/>
+          </a:p>
+        </p:txBody>
+      </p:sp>
+      <p:sp>
+        <p:nvSpPr>
+          <p:cNvPr id="10" name="TextBox 9"/>
           <p:cNvSpPr txBox="1"/>
           <p:nvPr/>
         </p:nvSpPr>
         <p:spPr>
           <a:xfrm>
-            <a:off x="548640" y="6446520"/>
-            <a:ext cx="11064240" cy="320040"/>
+            <a:off x="777240" y="5833872"/>
+            <a:ext cx="10607040" cy="457200"/>
           </a:xfrm>
           <a:prstGeom prst="rect">
             <a:avLst/>
@@ -6680,14 +8410,15 @@
           </a:bodyPr>
           <a:lstStyle/>
           <a:p>
-            <a:r>
-              <a:rPr sz="1100">
-                <a:solidFill>
-                  <a:srgbClr val="595659"/>
-                </a:solidFill>
-                <a:latin typeface="Calibri"/>
-              </a:rPr>
-              <a:t>Failures — Final Year Project Defence</a:t>
+            <a:pPr algn="l"/>
+            <a:r>
+              <a:rPr sz="1300" i="1">
+                <a:solidFill>
+                  <a:srgbClr val="1B3A5C"/>
+                </a:solidFill>
+                <a:latin typeface="Calibri"/>
+              </a:rPr>
+              <a:t>This qualifies the harness — so trust it on the blind study next.</a:t>
             </a:r>
           </a:p>
         </p:txBody>
@@ -6718,8 +8449,8 @@
         </p:nvSpPr>
         <p:spPr>
           <a:xfrm>
-            <a:off x="548640" y="228600"/>
-            <a:ext cx="11064240" cy="914400"/>
+            <a:off x="548640" y="201168"/>
+            <a:ext cx="11064240" cy="292608"/>
           </a:xfrm>
           <a:prstGeom prst="rect">
             <a:avLst/>
@@ -6733,33 +8464,67 @@
           <a:lstStyle/>
           <a:p>
             <a:r>
-              <a:rPr sz="2800" b="1">
-                <a:solidFill>
-                  <a:srgbClr val="1F3864"/>
-                </a:solidFill>
-                <a:latin typeface="Calibri"/>
-              </a:rPr>
-              <a:t>Results II — blind agent study</a:t>
-            </a:r>
-          </a:p>
-        </p:txBody>
-      </p:sp>
-      <p:sp>
-        <p:nvSpPr>
-          <p:cNvPr id="3" name="Rectangle 2"/>
+              <a:rPr sz="1200" b="1">
+                <a:solidFill>
+                  <a:srgbClr val="C98A1F"/>
+                </a:solidFill>
+                <a:latin typeface="Calibri"/>
+              </a:rPr>
+              <a:t>08 · RESULTS II</a:t>
+            </a:r>
+          </a:p>
+        </p:txBody>
+      </p:sp>
+      <p:sp>
+        <p:nvSpPr>
+          <p:cNvPr id="3" name="TextBox 2"/>
+          <p:cNvSpPr txBox="1"/>
+          <p:nvPr/>
+        </p:nvSpPr>
+        <p:spPr>
+          <a:xfrm>
+            <a:off x="548640" y="475488"/>
+            <a:ext cx="11064240" cy="685800"/>
+          </a:xfrm>
+          <a:prstGeom prst="rect">
+            <a:avLst/>
+          </a:prstGeom>
+          <a:noFill/>
+        </p:spPr>
+        <p:txBody>
+          <a:bodyPr wrap="none">
+            <a:spAutoFit/>
+          </a:bodyPr>
+          <a:lstStyle/>
+          <a:p>
+            <a:r>
+              <a:rPr sz="2700" b="1">
+                <a:solidFill>
+                  <a:srgbClr val="1B3A5C"/>
+                </a:solidFill>
+                <a:latin typeface="Calibri"/>
+              </a:rPr>
+              <a:t>Consistent direction across all three agents</a:t>
+            </a:r>
+          </a:p>
+        </p:txBody>
+      </p:sp>
+      <p:sp>
+        <p:nvSpPr>
+          <p:cNvPr id="4" name="Rectangle 3"/>
           <p:cNvSpPr/>
           <p:nvPr/>
         </p:nvSpPr>
         <p:spPr>
           <a:xfrm>
-            <a:off x="548640" y="1051560"/>
-            <a:ext cx="11064240" cy="25400"/>
+            <a:off x="548640" y="1207008"/>
+            <a:ext cx="1463040" cy="38100"/>
           </a:xfrm>
           <a:prstGeom prst="rect">
             <a:avLst/>
           </a:prstGeom>
           <a:solidFill>
-            <a:srgbClr val="1F3864"/>
+            <a:srgbClr val="C98A1F"/>
           </a:solidFill>
           <a:ln>
             <a:noFill/>
@@ -6789,14 +8554,83 @@
       </p:sp>
       <p:sp>
         <p:nvSpPr>
-          <p:cNvPr id="4" name="TextBox 3"/>
+          <p:cNvPr id="5" name="TextBox 4"/>
           <p:cNvSpPr txBox="1"/>
           <p:nvPr/>
         </p:nvSpPr>
         <p:spPr>
           <a:xfrm>
-            <a:off x="548640" y="1371600"/>
-            <a:ext cx="5303520" cy="4754880"/>
+            <a:off x="548640" y="6419088"/>
+            <a:ext cx="11091672" cy="320040"/>
+          </a:xfrm>
+          <a:prstGeom prst="rect">
+            <a:avLst/>
+          </a:prstGeom>
+          <a:noFill/>
+        </p:spPr>
+        <p:txBody>
+          <a:bodyPr wrap="none">
+            <a:spAutoFit/>
+          </a:bodyPr>
+          <a:lstStyle/>
+          <a:p>
+            <a:r>
+              <a:rPr sz="1000">
+                <a:solidFill>
+                  <a:srgbClr val="6B6B6B"/>
+                </a:solidFill>
+                <a:latin typeface="Calibri"/>
+              </a:rPr>
+              <a:t>Failures — Final Year Project Defence</a:t>
+            </a:r>
+          </a:p>
+        </p:txBody>
+      </p:sp>
+      <p:sp>
+        <p:nvSpPr>
+          <p:cNvPr id="6" name="TextBox 5"/>
+          <p:cNvSpPr txBox="1"/>
+          <p:nvPr/>
+        </p:nvSpPr>
+        <p:spPr>
+          <a:xfrm>
+            <a:off x="10424160" y="6419088"/>
+            <a:ext cx="1216152" cy="320040"/>
+          </a:xfrm>
+          <a:prstGeom prst="rect">
+            <a:avLst/>
+          </a:prstGeom>
+          <a:noFill/>
+        </p:spPr>
+        <p:txBody>
+          <a:bodyPr wrap="none">
+            <a:spAutoFit/>
+          </a:bodyPr>
+          <a:lstStyle/>
+          <a:p>
+            <a:pPr algn="r"/>
+            <a:r>
+              <a:rPr sz="1000">
+                <a:solidFill>
+                  <a:srgbClr val="6B6B6B"/>
+                </a:solidFill>
+                <a:latin typeface="Calibri"/>
+              </a:rPr>
+              <a:t>09 / 11</a:t>
+            </a:r>
+          </a:p>
+        </p:txBody>
+      </p:sp>
+      <p:sp>
+        <p:nvSpPr>
+          <p:cNvPr id="7" name="TextBox 6"/>
+          <p:cNvSpPr txBox="1"/>
+          <p:nvPr/>
+        </p:nvSpPr>
+        <p:spPr>
+          <a:xfrm>
+            <a:off x="548640" y="1508760"/>
+            <a:ext cx="5120640" cy="3291840"/>
           </a:xfrm>
           <a:prstGeom prst="rect">
             <a:avLst/>
@@ -6815,9 +8649,18 @@
               </a:spcAft>
             </a:pPr>
             <a:r>
-              <a:rPr sz="1700">
-                <a:solidFill>
-                  <a:srgbClr val="333333"/>
+              <a:rPr sz="1800" b="1">
+                <a:solidFill>
+                  <a:srgbClr val="C98A1F"/>
+                </a:solidFill>
+                <a:latin typeface="Calibri"/>
+              </a:rPr>
+              <a:t>▸ </a:t>
+            </a:r>
+            <a:r>
+              <a:rPr sz="1800" b="1">
+                <a:solidFill>
+                  <a:srgbClr val="1B3A5C"/>
                 </a:solidFill>
                 <a:latin typeface="Calibri"/>
               </a:rPr>
@@ -6831,13 +8674,22 @@
               </a:spcAft>
             </a:pPr>
             <a:r>
-              <a:rPr sz="1700">
-                <a:solidFill>
-                  <a:srgbClr val="333333"/>
-                </a:solidFill>
-                <a:latin typeface="Calibri"/>
-              </a:rPr>
-              <a:t>HIGH findings never rose in any pair — and fell 13 → 1 overall.</a:t>
+              <a:rPr sz="1800" b="1">
+                <a:solidFill>
+                  <a:srgbClr val="C98A1F"/>
+                </a:solidFill>
+                <a:latin typeface="Calibri"/>
+              </a:rPr>
+              <a:t>▸ </a:t>
+            </a:r>
+            <a:r>
+              <a:rPr sz="1800" b="1">
+                <a:solidFill>
+                  <a:srgbClr val="1B3A5C"/>
+                </a:solidFill>
+                <a:latin typeface="Calibri"/>
+              </a:rPr>
+              <a:t>HIGH findings never rose — and fell 13 → 1 overall.</a:t>
             </a:r>
           </a:p>
           <a:p>
@@ -6847,9 +8699,18 @@
               </a:spcAft>
             </a:pPr>
             <a:r>
-              <a:rPr sz="1700">
-                <a:solidFill>
-                  <a:srgbClr val="333333"/>
+              <a:rPr sz="1800" b="1">
+                <a:solidFill>
+                  <a:srgbClr val="C98A1F"/>
+                </a:solidFill>
+                <a:latin typeface="Calibri"/>
+              </a:rPr>
+              <a:t>▸ </a:t>
+            </a:r>
+            <a:r>
+              <a:rPr sz="1800" b="1">
+                <a:solidFill>
+                  <a:srgbClr val="1B3A5C"/>
                 </a:solidFill>
                 <a:latin typeface="Calibri"/>
               </a:rPr>
@@ -6860,7 +8721,7 @@
       </p:sp>
       <p:pic>
         <p:nvPicPr>
-          <p:cNvPr id="5" name="Picture 4" descr="fig42_agents.png"/>
+          <p:cNvPr id="8" name="Picture 7" descr="fig42_agents.png"/>
           <p:cNvPicPr>
             <a:picLocks noChangeAspect="1"/>
           </p:cNvPicPr>
@@ -6875,7 +8736,7 @@
         <p:spPr>
           <a:xfrm>
             <a:off x="6126480" y="1463040"/>
-            <a:ext cx="5486400" cy="3840480"/>
+            <a:ext cx="5486400" cy="3931920"/>
           </a:xfrm>
           <a:prstGeom prst="rect">
             <a:avLst/>
@@ -6884,14 +8745,57 @@
       </p:pic>
       <p:sp>
         <p:nvSpPr>
-          <p:cNvPr id="6" name="TextBox 5"/>
+          <p:cNvPr id="9" name="Rectangle 8"/>
+          <p:cNvSpPr/>
+          <p:nvPr/>
+        </p:nvSpPr>
+        <p:spPr>
+          <a:xfrm>
+            <a:off x="548640" y="5806440"/>
+            <a:ext cx="11091672" cy="502920"/>
+          </a:xfrm>
+          <a:prstGeom prst="rect">
+            <a:avLst/>
+          </a:prstGeom>
+          <a:solidFill>
+            <a:srgbClr val="FDF3E3"/>
+          </a:solidFill>
+          <a:ln>
+            <a:noFill/>
+          </a:ln>
+        </p:spPr>
+        <p:style>
+          <a:lnRef idx="1">
+            <a:schemeClr val="accent1"/>
+          </a:lnRef>
+          <a:fillRef idx="3">
+            <a:schemeClr val="accent1"/>
+          </a:fillRef>
+          <a:effectRef idx="2">
+            <a:schemeClr val="accent1"/>
+          </a:effectRef>
+          <a:fontRef idx="minor">
+            <a:schemeClr val="lt1"/>
+          </a:fontRef>
+        </p:style>
+        <p:txBody>
+          <a:bodyPr rtlCol="0" anchor="ctr"/>
+          <a:lstStyle/>
+          <a:p>
+            <a:pPr algn="ctr"/>
+          </a:p>
+        </p:txBody>
+      </p:sp>
+      <p:sp>
+        <p:nvSpPr>
+          <p:cNvPr id="10" name="TextBox 9"/>
           <p:cNvSpPr txBox="1"/>
           <p:nvPr/>
         </p:nvSpPr>
         <p:spPr>
           <a:xfrm>
-            <a:off x="548640" y="6446520"/>
-            <a:ext cx="11064240" cy="320040"/>
+            <a:off x="777240" y="5833872"/>
+            <a:ext cx="10607040" cy="457200"/>
           </a:xfrm>
           <a:prstGeom prst="rect">
             <a:avLst/>
@@ -6904,14 +8808,15 @@
           </a:bodyPr>
           <a:lstStyle/>
           <a:p>
-            <a:r>
-              <a:rPr sz="1100">
-                <a:solidFill>
-                  <a:srgbClr val="595659"/>
-                </a:solidFill>
-                <a:latin typeface="Calibri"/>
-              </a:rPr>
-              <a:t>Failures — Final Year Project Defence</a:t>
+            <a:pPr algn="l"/>
+            <a:r>
+              <a:rPr sz="1300" i="1">
+                <a:solidFill>
+                  <a:srgbClr val="1B3A5C"/>
+                </a:solidFill>
+                <a:latin typeface="Calibri"/>
+              </a:rPr>
+              <a:t>Direction holds per agent: 6/6, 5/5, 5/6 — no single model carries it.</a:t>
             </a:r>
           </a:p>
         </p:txBody>

</xml_diff>